<commit_message>
Split margin graphs into separate Raipur and NCR slides
Nett Margin Billet and Margin TMT now each get two slides
(one per market) instead of grouped bars on a single slide.
Total: 10 slides (1 title + 5 materials + 4 margins).

https://claude.ai/code/session_01FNQ5sjxusLBez8dDxNj6Lb
</commit_message>
<xml_diff>
--- a/output/material_change_graphs.pptx
+++ b/output/material_change_graphs.pptx
@@ -13,6 +13,8 @@
     <p:sldId id="261" r:id="rId12"/>
     <p:sldId id="262" r:id="rId13"/>
     <p:sldId id="263" r:id="rId14"/>
+    <p:sldId id="264" r:id="rId15"/>
+    <p:sldId id="265" r:id="rId16"/>
   </p:sldIdLst>
   <p:sldSz cx="12191695" cy="6858000" type="screen4x3"/>
   <p:notesSz cx="6858000" cy="9144000"/>
@@ -3243,6 +3245,83 @@
 </p:sld>
 </file>
 
+<file path=ppt/slides/slide10.xml><?xml version="1.0" encoding="utf-8"?>
+<p:sld xmlns:a="http://schemas.openxmlformats.org/drawingml/2006/main" xmlns:p="http://schemas.openxmlformats.org/presentationml/2006/main" xmlns:r="http://schemas.openxmlformats.org/officeDocument/2006/relationships">
+  <p:cSld>
+    <p:spTree>
+      <p:nvGrpSpPr>
+        <p:cNvPr id="1" name=""/>
+        <p:cNvGrpSpPr/>
+        <p:nvPr/>
+      </p:nvGrpSpPr>
+      <p:grpSpPr/>
+      <p:sp>
+        <p:nvSpPr>
+          <p:cNvPr id="2" name="TextBox 1"/>
+          <p:cNvSpPr txBox="1"/>
+          <p:nvPr/>
+        </p:nvSpPr>
+        <p:spPr>
+          <a:xfrm>
+            <a:off x="457200" y="182880"/>
+            <a:ext cx="11277295" cy="548640"/>
+          </a:xfrm>
+          <a:prstGeom prst="rect">
+            <a:avLst/>
+          </a:prstGeom>
+          <a:noFill/>
+        </p:spPr>
+        <p:txBody>
+          <a:bodyPr wrap="none">
+            <a:spAutoFit/>
+          </a:bodyPr>
+          <a:lstStyle/>
+          <a:p>
+            <a:pPr algn="l">
+              <a:defRPr sz="1800" b="1">
+                <a:solidFill>
+                  <a:srgbClr val="212121"/>
+                </a:solidFill>
+              </a:defRPr>
+            </a:pPr>
+            <a:r>
+              <a:t>Margin TMT (NCR) - INR/MT</a:t>
+            </a:r>
+          </a:p>
+        </p:txBody>
+      </p:sp>
+      <p:pic>
+        <p:nvPicPr>
+          <p:cNvPr id="3" name="Picture 2" descr="Margin_TMT_(NCR).png"/>
+          <p:cNvPicPr>
+            <a:picLocks noChangeAspect="1"/>
+          </p:cNvPicPr>
+          <p:nvPr/>
+        </p:nvPicPr>
+        <p:blipFill>
+          <a:blip r:embed="rId2"/>
+          <a:stretch>
+            <a:fillRect/>
+          </a:stretch>
+        </p:blipFill>
+        <p:spPr>
+          <a:xfrm>
+            <a:off x="274320" y="822960"/>
+            <a:ext cx="11612880" cy="5760720"/>
+          </a:xfrm>
+          <a:prstGeom prst="rect">
+            <a:avLst/>
+          </a:prstGeom>
+        </p:spPr>
+      </p:pic>
+    </p:spTree>
+  </p:cSld>
+  <p:clrMapOvr>
+    <a:masterClrMapping/>
+  </p:clrMapOvr>
+</p:sld>
+</file>
+
 <file path=ppt/slides/slide2.xml><?xml version="1.0" encoding="utf-8"?>
 <p:sld xmlns:a="http://schemas.openxmlformats.org/drawingml/2006/main" xmlns:p="http://schemas.openxmlformats.org/presentationml/2006/main" xmlns:r="http://schemas.openxmlformats.org/officeDocument/2006/relationships">
   <p:cSld>
@@ -3668,14 +3747,14 @@
               </a:defRPr>
             </a:pPr>
             <a:r>
-              <a:t>Nett Margin Billet (Raipur &amp; NCR) - INR/MT</a:t>
+              <a:t>Nett Margin Billet (Raipur) - INR/MT</a:t>
             </a:r>
           </a:p>
         </p:txBody>
       </p:sp>
       <p:pic>
         <p:nvPicPr>
-          <p:cNvPr id="3" name="Picture 2" descr="Nett_Margin_Billet.png"/>
+          <p:cNvPr id="3" name="Picture 2" descr="Nett_Margin_Billet_(Raipur).png"/>
           <p:cNvPicPr>
             <a:picLocks noChangeAspect="1"/>
           </p:cNvPicPr>
@@ -3745,14 +3824,91 @@
               </a:defRPr>
             </a:pPr>
             <a:r>
-              <a:t>Margin TMT (Raipur &amp; NCR) - INR/MT</a:t>
+              <a:t>Nett Margin Billet (NCR) - INR/MT</a:t>
             </a:r>
           </a:p>
         </p:txBody>
       </p:sp>
       <p:pic>
         <p:nvPicPr>
-          <p:cNvPr id="3" name="Picture 2" descr="Margin_TMT.png"/>
+          <p:cNvPr id="3" name="Picture 2" descr="Nett_Margin_Billet_(NCR).png"/>
+          <p:cNvPicPr>
+            <a:picLocks noChangeAspect="1"/>
+          </p:cNvPicPr>
+          <p:nvPr/>
+        </p:nvPicPr>
+        <p:blipFill>
+          <a:blip r:embed="rId2"/>
+          <a:stretch>
+            <a:fillRect/>
+          </a:stretch>
+        </p:blipFill>
+        <p:spPr>
+          <a:xfrm>
+            <a:off x="274320" y="822960"/>
+            <a:ext cx="11612880" cy="5760720"/>
+          </a:xfrm>
+          <a:prstGeom prst="rect">
+            <a:avLst/>
+          </a:prstGeom>
+        </p:spPr>
+      </p:pic>
+    </p:spTree>
+  </p:cSld>
+  <p:clrMapOvr>
+    <a:masterClrMapping/>
+  </p:clrMapOvr>
+</p:sld>
+</file>
+
+<file path=ppt/slides/slide9.xml><?xml version="1.0" encoding="utf-8"?>
+<p:sld xmlns:a="http://schemas.openxmlformats.org/drawingml/2006/main" xmlns:p="http://schemas.openxmlformats.org/presentationml/2006/main" xmlns:r="http://schemas.openxmlformats.org/officeDocument/2006/relationships">
+  <p:cSld>
+    <p:spTree>
+      <p:nvGrpSpPr>
+        <p:cNvPr id="1" name=""/>
+        <p:cNvGrpSpPr/>
+        <p:nvPr/>
+      </p:nvGrpSpPr>
+      <p:grpSpPr/>
+      <p:sp>
+        <p:nvSpPr>
+          <p:cNvPr id="2" name="TextBox 1"/>
+          <p:cNvSpPr txBox="1"/>
+          <p:nvPr/>
+        </p:nvSpPr>
+        <p:spPr>
+          <a:xfrm>
+            <a:off x="457200" y="182880"/>
+            <a:ext cx="11277295" cy="548640"/>
+          </a:xfrm>
+          <a:prstGeom prst="rect">
+            <a:avLst/>
+          </a:prstGeom>
+          <a:noFill/>
+        </p:spPr>
+        <p:txBody>
+          <a:bodyPr wrap="none">
+            <a:spAutoFit/>
+          </a:bodyPr>
+          <a:lstStyle/>
+          <a:p>
+            <a:pPr algn="l">
+              <a:defRPr sz="1800" b="1">
+                <a:solidFill>
+                  <a:srgbClr val="212121"/>
+                </a:solidFill>
+              </a:defRPr>
+            </a:pPr>
+            <a:r>
+              <a:t>Margin TMT (Raipur) - INR/MT</a:t>
+            </a:r>
+          </a:p>
+        </p:txBody>
+      </p:sp>
+      <p:pic>
+        <p:nvPicPr>
+          <p:cNvPr id="3" name="Picture 2" descr="Margin_TMT_(Raipur).png"/>
           <p:cNvPicPr>
             <a:picLocks noChangeAspect="1"/>
           </p:cNvPicPr>

</xml_diff>

<commit_message>
Fix chart visibility: use outEnd labels with dark text and visible axis
Data labels were white (FFFFFF) with inEnd position, making them
invisible against white background for small/negative bars. Changed to
outEnd position with blue text, and enabled value axis with light
grid lines for better readability.

https://claude.ai/code/session_01FNQ5sjxusLBez8dDxNj6Lb
</commit_message>
<xml_diff>
--- a/output/material_change_graphs.pptx
+++ b/output/material_change_graphs.pptx
@@ -156,16 +156,15 @@
               <a:lstStyle/>
               <a:p>
                 <a:pPr>
-                  <a:defRPr b="1" i="0" strike="noStrike" sz="1100" u="none">
+                  <a:defRPr b="1" i="0" strike="noStrike" sz="1000" u="none">
                     <a:solidFill>
-                      <a:srgbClr val="FFFFFF"/>
+                      <a:srgbClr val="213366"/>
                     </a:solidFill>
                     <a:latin typeface="Calibri"/>
                   </a:defRPr>
                 </a:pPr>
               </a:p>
             </c:txPr>
-            <c:dLblPos val="inEnd"/>
             <c:showLegendKey val="0"/>
             <c:showVal val="1"/>
             <c:showCatName val="0"/>
@@ -297,16 +296,15 @@
             <a:lstStyle/>
             <a:p>
               <a:pPr>
-                <a:defRPr b="1" i="0" strike="noStrike" sz="1100" u="none">
+                <a:defRPr b="1" i="0" strike="noStrike" sz="1000" u="none">
                   <a:solidFill>
-                    <a:srgbClr val="FFFFFF"/>
+                    <a:srgbClr val="213366"/>
                   </a:solidFill>
                   <a:latin typeface="Calibri"/>
                 </a:defRPr>
               </a:pPr>
             </a:p>
           </c:txPr>
-          <c:dLblPos val="inEnd"/>
           <c:showLegendKey val="0"/>
           <c:showVal val="1"/>
           <c:showCatName val="0"/>
@@ -367,8 +365,19 @@
         <c:scaling>
           <c:orientation val="minMax"/>
         </c:scaling>
-        <c:delete val="1"/>
+        <c:delete val="0"/>
         <c:axPos val="l"/>
+        <c:majorGridlines>
+          <c:spPr>
+            <a:ln w="6350" cap="flat">
+              <a:solidFill>
+                <a:srgbClr val="E0E0E0"/>
+              </a:solidFill>
+              <a:prstDash val="dash"/>
+              <a:round/>
+            </a:ln>
+          </c:spPr>
+        </c:majorGridlines>
         <c:numFmt formatCode="General" sourceLinked="0"/>
         <c:majorTickMark val="out"/>
         <c:minorTickMark val="none"/>
@@ -387,11 +396,11 @@
           <a:lstStyle/>
           <a:p>
             <a:pPr>
-              <a:defRPr sz="1200" b="0" i="0" u="none" strike="noStrike">
+              <a:defRPr sz="1000" b="0" i="0" u="none" strike="noStrike">
                 <a:solidFill>
-                  <a:srgbClr val="000000"/>
+                  <a:srgbClr val="7F7F7F"/>
                 </a:solidFill>
-                <a:latin typeface="Arial"/>
+                <a:latin typeface="Calibri"/>
               </a:defRPr>
             </a:pPr>
             <a:endParaRPr lang="en-US"/>
@@ -467,16 +476,15 @@
               <a:lstStyle/>
               <a:p>
                 <a:pPr>
-                  <a:defRPr b="1" i="0" strike="noStrike" sz="1100" u="none">
+                  <a:defRPr b="1" i="0" strike="noStrike" sz="1000" u="none">
                     <a:solidFill>
-                      <a:srgbClr val="FFFFFF"/>
+                      <a:srgbClr val="213366"/>
                     </a:solidFill>
                     <a:latin typeface="Calibri"/>
                   </a:defRPr>
                 </a:pPr>
               </a:p>
             </c:txPr>
-            <c:dLblPos val="inEnd"/>
             <c:showLegendKey val="0"/>
             <c:showVal val="1"/>
             <c:showCatName val="0"/>
@@ -608,16 +616,15 @@
             <a:lstStyle/>
             <a:p>
               <a:pPr>
-                <a:defRPr b="1" i="0" strike="noStrike" sz="1100" u="none">
+                <a:defRPr b="1" i="0" strike="noStrike" sz="1000" u="none">
                   <a:solidFill>
-                    <a:srgbClr val="FFFFFF"/>
+                    <a:srgbClr val="213366"/>
                   </a:solidFill>
                   <a:latin typeface="Calibri"/>
                 </a:defRPr>
               </a:pPr>
             </a:p>
           </c:txPr>
-          <c:dLblPos val="inEnd"/>
           <c:showLegendKey val="0"/>
           <c:showVal val="1"/>
           <c:showCatName val="0"/>
@@ -678,8 +685,19 @@
         <c:scaling>
           <c:orientation val="minMax"/>
         </c:scaling>
-        <c:delete val="1"/>
+        <c:delete val="0"/>
         <c:axPos val="l"/>
+        <c:majorGridlines>
+          <c:spPr>
+            <a:ln w="6350" cap="flat">
+              <a:solidFill>
+                <a:srgbClr val="E0E0E0"/>
+              </a:solidFill>
+              <a:prstDash val="dash"/>
+              <a:round/>
+            </a:ln>
+          </c:spPr>
+        </c:majorGridlines>
         <c:numFmt formatCode="General" sourceLinked="0"/>
         <c:majorTickMark val="out"/>
         <c:minorTickMark val="none"/>
@@ -698,11 +716,11 @@
           <a:lstStyle/>
           <a:p>
             <a:pPr>
-              <a:defRPr sz="1200" b="0" i="0" u="none" strike="noStrike">
+              <a:defRPr sz="1000" b="0" i="0" u="none" strike="noStrike">
                 <a:solidFill>
-                  <a:srgbClr val="000000"/>
+                  <a:srgbClr val="7F7F7F"/>
                 </a:solidFill>
-                <a:latin typeface="Arial"/>
+                <a:latin typeface="Calibri"/>
               </a:defRPr>
             </a:pPr>
             <a:endParaRPr lang="en-US"/>
@@ -778,16 +796,15 @@
               <a:lstStyle/>
               <a:p>
                 <a:pPr>
-                  <a:defRPr b="1" i="0" strike="noStrike" sz="1100" u="none">
+                  <a:defRPr b="1" i="0" strike="noStrike" sz="1000" u="none">
                     <a:solidFill>
-                      <a:srgbClr val="FFFFFF"/>
+                      <a:srgbClr val="213366"/>
                     </a:solidFill>
                     <a:latin typeface="Calibri"/>
                   </a:defRPr>
                 </a:pPr>
               </a:p>
             </c:txPr>
-            <c:dLblPos val="inEnd"/>
             <c:showLegendKey val="0"/>
             <c:showVal val="1"/>
             <c:showCatName val="0"/>
@@ -940,16 +957,15 @@
               <a:lstStyle/>
               <a:p>
                 <a:pPr>
-                  <a:defRPr b="1" i="0" strike="noStrike" sz="1100" u="none">
+                  <a:defRPr b="1" i="0" strike="noStrike" sz="1000" u="none">
                     <a:solidFill>
-                      <a:srgbClr val="FFFFFF"/>
+                      <a:srgbClr val="213366"/>
                     </a:solidFill>
                     <a:latin typeface="Calibri"/>
                   </a:defRPr>
                 </a:pPr>
               </a:p>
             </c:txPr>
-            <c:dLblPos val="inEnd"/>
             <c:showLegendKey val="0"/>
             <c:showVal val="1"/>
             <c:showCatName val="0"/>
@@ -1081,16 +1097,15 @@
             <a:lstStyle/>
             <a:p>
               <a:pPr>
-                <a:defRPr b="1" i="0" strike="noStrike" sz="1100" u="none">
+                <a:defRPr b="1" i="0" strike="noStrike" sz="1000" u="none">
                   <a:solidFill>
-                    <a:srgbClr val="FFFFFF"/>
+                    <a:srgbClr val="213366"/>
                   </a:solidFill>
                   <a:latin typeface="Calibri"/>
                 </a:defRPr>
               </a:pPr>
             </a:p>
           </c:txPr>
-          <c:dLblPos val="inEnd"/>
           <c:showLegendKey val="0"/>
           <c:showVal val="1"/>
           <c:showCatName val="0"/>
@@ -1151,8 +1166,19 @@
         <c:scaling>
           <c:orientation val="minMax"/>
         </c:scaling>
-        <c:delete val="1"/>
+        <c:delete val="0"/>
         <c:axPos val="l"/>
+        <c:majorGridlines>
+          <c:spPr>
+            <a:ln w="6350" cap="flat">
+              <a:solidFill>
+                <a:srgbClr val="E0E0E0"/>
+              </a:solidFill>
+              <a:prstDash val="dash"/>
+              <a:round/>
+            </a:ln>
+          </c:spPr>
+        </c:majorGridlines>
         <c:numFmt formatCode="General" sourceLinked="0"/>
         <c:majorTickMark val="out"/>
         <c:minorTickMark val="none"/>
@@ -1171,11 +1197,11 @@
           <a:lstStyle/>
           <a:p>
             <a:pPr>
-              <a:defRPr sz="1200" b="0" i="0" u="none" strike="noStrike">
+              <a:defRPr sz="1000" b="0" i="0" u="none" strike="noStrike">
                 <a:solidFill>
-                  <a:srgbClr val="000000"/>
+                  <a:srgbClr val="7F7F7F"/>
                 </a:solidFill>
-                <a:latin typeface="Arial"/>
+                <a:latin typeface="Calibri"/>
               </a:defRPr>
             </a:pPr>
             <a:endParaRPr lang="en-US"/>
@@ -1271,16 +1297,15 @@
               <a:lstStyle/>
               <a:p>
                 <a:pPr>
-                  <a:defRPr b="1" i="0" strike="noStrike" sz="1100" u="none">
+                  <a:defRPr b="1" i="0" strike="noStrike" sz="1000" u="none">
                     <a:solidFill>
-                      <a:srgbClr val="FFFFFF"/>
+                      <a:srgbClr val="213366"/>
                     </a:solidFill>
                     <a:latin typeface="Calibri"/>
                   </a:defRPr>
                 </a:pPr>
               </a:p>
             </c:txPr>
-            <c:dLblPos val="inEnd"/>
             <c:showLegendKey val="0"/>
             <c:showVal val="1"/>
             <c:showCatName val="0"/>
@@ -1412,16 +1437,15 @@
             <a:lstStyle/>
             <a:p>
               <a:pPr>
-                <a:defRPr b="1" i="0" strike="noStrike" sz="1100" u="none">
+                <a:defRPr b="1" i="0" strike="noStrike" sz="1000" u="none">
                   <a:solidFill>
-                    <a:srgbClr val="FFFFFF"/>
+                    <a:srgbClr val="213366"/>
                   </a:solidFill>
                   <a:latin typeface="Calibri"/>
                 </a:defRPr>
               </a:pPr>
             </a:p>
           </c:txPr>
-          <c:dLblPos val="inEnd"/>
           <c:showLegendKey val="0"/>
           <c:showVal val="1"/>
           <c:showCatName val="0"/>
@@ -1482,8 +1506,19 @@
         <c:scaling>
           <c:orientation val="minMax"/>
         </c:scaling>
-        <c:delete val="1"/>
+        <c:delete val="0"/>
         <c:axPos val="l"/>
+        <c:majorGridlines>
+          <c:spPr>
+            <a:ln w="6350" cap="flat">
+              <a:solidFill>
+                <a:srgbClr val="E0E0E0"/>
+              </a:solidFill>
+              <a:prstDash val="dash"/>
+              <a:round/>
+            </a:ln>
+          </c:spPr>
+        </c:majorGridlines>
         <c:numFmt formatCode="General" sourceLinked="0"/>
         <c:majorTickMark val="out"/>
         <c:minorTickMark val="none"/>
@@ -1502,11 +1537,11 @@
           <a:lstStyle/>
           <a:p>
             <a:pPr>
-              <a:defRPr sz="1200" b="0" i="0" u="none" strike="noStrike">
+              <a:defRPr sz="1000" b="0" i="0" u="none" strike="noStrike">
                 <a:solidFill>
-                  <a:srgbClr val="000000"/>
+                  <a:srgbClr val="7F7F7F"/>
                 </a:solidFill>
-                <a:latin typeface="Arial"/>
+                <a:latin typeface="Calibri"/>
               </a:defRPr>
             </a:pPr>
             <a:endParaRPr lang="en-US"/>
@@ -1582,16 +1617,15 @@
               <a:lstStyle/>
               <a:p>
                 <a:pPr>
-                  <a:defRPr b="1" i="0" strike="noStrike" sz="1100" u="none">
+                  <a:defRPr b="1" i="0" strike="noStrike" sz="1000" u="none">
                     <a:solidFill>
-                      <a:srgbClr val="FFFFFF"/>
+                      <a:srgbClr val="213366"/>
                     </a:solidFill>
                     <a:latin typeface="Calibri"/>
                   </a:defRPr>
                 </a:pPr>
               </a:p>
             </c:txPr>
-            <c:dLblPos val="inEnd"/>
             <c:showLegendKey val="0"/>
             <c:showVal val="1"/>
             <c:showCatName val="0"/>
@@ -1723,16 +1757,15 @@
             <a:lstStyle/>
             <a:p>
               <a:pPr>
-                <a:defRPr b="1" i="0" strike="noStrike" sz="1100" u="none">
+                <a:defRPr b="1" i="0" strike="noStrike" sz="1000" u="none">
                   <a:solidFill>
-                    <a:srgbClr val="FFFFFF"/>
+                    <a:srgbClr val="213366"/>
                   </a:solidFill>
                   <a:latin typeface="Calibri"/>
                 </a:defRPr>
               </a:pPr>
             </a:p>
           </c:txPr>
-          <c:dLblPos val="inEnd"/>
           <c:showLegendKey val="0"/>
           <c:showVal val="1"/>
           <c:showCatName val="0"/>
@@ -1793,8 +1826,19 @@
         <c:scaling>
           <c:orientation val="minMax"/>
         </c:scaling>
-        <c:delete val="1"/>
+        <c:delete val="0"/>
         <c:axPos val="l"/>
+        <c:majorGridlines>
+          <c:spPr>
+            <a:ln w="6350" cap="flat">
+              <a:solidFill>
+                <a:srgbClr val="E0E0E0"/>
+              </a:solidFill>
+              <a:prstDash val="dash"/>
+              <a:round/>
+            </a:ln>
+          </c:spPr>
+        </c:majorGridlines>
         <c:numFmt formatCode="General" sourceLinked="0"/>
         <c:majorTickMark val="out"/>
         <c:minorTickMark val="none"/>
@@ -1813,11 +1857,11 @@
           <a:lstStyle/>
           <a:p>
             <a:pPr>
-              <a:defRPr sz="1200" b="0" i="0" u="none" strike="noStrike">
+              <a:defRPr sz="1000" b="0" i="0" u="none" strike="noStrike">
                 <a:solidFill>
-                  <a:srgbClr val="000000"/>
+                  <a:srgbClr val="7F7F7F"/>
                 </a:solidFill>
-                <a:latin typeface="Arial"/>
+                <a:latin typeface="Calibri"/>
               </a:defRPr>
             </a:pPr>
             <a:endParaRPr lang="en-US"/>
@@ -1893,16 +1937,15 @@
               <a:lstStyle/>
               <a:p>
                 <a:pPr>
-                  <a:defRPr b="1" i="0" strike="noStrike" sz="1100" u="none">
+                  <a:defRPr b="1" i="0" strike="noStrike" sz="1000" u="none">
                     <a:solidFill>
-                      <a:srgbClr val="FFFFFF"/>
+                      <a:srgbClr val="213366"/>
                     </a:solidFill>
                     <a:latin typeface="Calibri"/>
                   </a:defRPr>
                 </a:pPr>
               </a:p>
             </c:txPr>
-            <c:dLblPos val="inEnd"/>
             <c:showLegendKey val="0"/>
             <c:showVal val="1"/>
             <c:showCatName val="0"/>
@@ -2034,16 +2077,15 @@
             <a:lstStyle/>
             <a:p>
               <a:pPr>
-                <a:defRPr b="1" i="0" strike="noStrike" sz="1100" u="none">
+                <a:defRPr b="1" i="0" strike="noStrike" sz="1000" u="none">
                   <a:solidFill>
-                    <a:srgbClr val="FFFFFF"/>
+                    <a:srgbClr val="213366"/>
                   </a:solidFill>
                   <a:latin typeface="Calibri"/>
                 </a:defRPr>
               </a:pPr>
             </a:p>
           </c:txPr>
-          <c:dLblPos val="inEnd"/>
           <c:showLegendKey val="0"/>
           <c:showVal val="1"/>
           <c:showCatName val="0"/>
@@ -2104,8 +2146,19 @@
         <c:scaling>
           <c:orientation val="minMax"/>
         </c:scaling>
-        <c:delete val="1"/>
+        <c:delete val="0"/>
         <c:axPos val="l"/>
+        <c:majorGridlines>
+          <c:spPr>
+            <a:ln w="6350" cap="flat">
+              <a:solidFill>
+                <a:srgbClr val="E0E0E0"/>
+              </a:solidFill>
+              <a:prstDash val="dash"/>
+              <a:round/>
+            </a:ln>
+          </c:spPr>
+        </c:majorGridlines>
         <c:numFmt formatCode="General" sourceLinked="0"/>
         <c:majorTickMark val="out"/>
         <c:minorTickMark val="none"/>
@@ -2124,11 +2177,11 @@
           <a:lstStyle/>
           <a:p>
             <a:pPr>
-              <a:defRPr sz="1200" b="0" i="0" u="none" strike="noStrike">
+              <a:defRPr sz="1000" b="0" i="0" u="none" strike="noStrike">
                 <a:solidFill>
-                  <a:srgbClr val="000000"/>
+                  <a:srgbClr val="7F7F7F"/>
                 </a:solidFill>
-                <a:latin typeface="Arial"/>
+                <a:latin typeface="Calibri"/>
               </a:defRPr>
             </a:pPr>
             <a:endParaRPr lang="en-US"/>
@@ -2204,16 +2257,15 @@
               <a:lstStyle/>
               <a:p>
                 <a:pPr>
-                  <a:defRPr b="1" i="0" strike="noStrike" sz="1100" u="none">
+                  <a:defRPr b="1" i="0" strike="noStrike" sz="1000" u="none">
                     <a:solidFill>
-                      <a:srgbClr val="FFFFFF"/>
+                      <a:srgbClr val="213366"/>
                     </a:solidFill>
                     <a:latin typeface="Calibri"/>
                   </a:defRPr>
                 </a:pPr>
               </a:p>
             </c:txPr>
-            <c:dLblPos val="inEnd"/>
             <c:showLegendKey val="0"/>
             <c:showVal val="1"/>
             <c:showCatName val="0"/>
@@ -2345,16 +2397,15 @@
             <a:lstStyle/>
             <a:p>
               <a:pPr>
-                <a:defRPr b="1" i="0" strike="noStrike" sz="1100" u="none">
+                <a:defRPr b="1" i="0" strike="noStrike" sz="1000" u="none">
                   <a:solidFill>
-                    <a:srgbClr val="FFFFFF"/>
+                    <a:srgbClr val="213366"/>
                   </a:solidFill>
                   <a:latin typeface="Calibri"/>
                 </a:defRPr>
               </a:pPr>
             </a:p>
           </c:txPr>
-          <c:dLblPos val="inEnd"/>
           <c:showLegendKey val="0"/>
           <c:showVal val="1"/>
           <c:showCatName val="0"/>
@@ -2415,8 +2466,19 @@
         <c:scaling>
           <c:orientation val="minMax"/>
         </c:scaling>
-        <c:delete val="1"/>
+        <c:delete val="0"/>
         <c:axPos val="l"/>
+        <c:majorGridlines>
+          <c:spPr>
+            <a:ln w="6350" cap="flat">
+              <a:solidFill>
+                <a:srgbClr val="E0E0E0"/>
+              </a:solidFill>
+              <a:prstDash val="dash"/>
+              <a:round/>
+            </a:ln>
+          </c:spPr>
+        </c:majorGridlines>
         <c:numFmt formatCode="General" sourceLinked="0"/>
         <c:majorTickMark val="out"/>
         <c:minorTickMark val="none"/>
@@ -2435,11 +2497,11 @@
           <a:lstStyle/>
           <a:p>
             <a:pPr>
-              <a:defRPr sz="1200" b="0" i="0" u="none" strike="noStrike">
+              <a:defRPr sz="1000" b="0" i="0" u="none" strike="noStrike">
                 <a:solidFill>
-                  <a:srgbClr val="000000"/>
+                  <a:srgbClr val="7F7F7F"/>
                 </a:solidFill>
-                <a:latin typeface="Arial"/>
+                <a:latin typeface="Calibri"/>
               </a:defRPr>
             </a:pPr>
             <a:endParaRPr lang="en-US"/>
@@ -2515,16 +2577,15 @@
               <a:lstStyle/>
               <a:p>
                 <a:pPr>
-                  <a:defRPr b="1" i="0" strike="noStrike" sz="1100" u="none">
+                  <a:defRPr b="1" i="0" strike="noStrike" sz="1000" u="none">
                     <a:solidFill>
-                      <a:srgbClr val="FFFFFF"/>
+                      <a:srgbClr val="213366"/>
                     </a:solidFill>
                     <a:latin typeface="Calibri"/>
                   </a:defRPr>
                 </a:pPr>
               </a:p>
             </c:txPr>
-            <c:dLblPos val="inEnd"/>
             <c:showLegendKey val="0"/>
             <c:showVal val="1"/>
             <c:showCatName val="0"/>
@@ -2656,16 +2717,15 @@
             <a:lstStyle/>
             <a:p>
               <a:pPr>
-                <a:defRPr b="1" i="0" strike="noStrike" sz="1100" u="none">
+                <a:defRPr b="1" i="0" strike="noStrike" sz="1000" u="none">
                   <a:solidFill>
-                    <a:srgbClr val="FFFFFF"/>
+                    <a:srgbClr val="213366"/>
                   </a:solidFill>
                   <a:latin typeface="Calibri"/>
                 </a:defRPr>
               </a:pPr>
             </a:p>
           </c:txPr>
-          <c:dLblPos val="inEnd"/>
           <c:showLegendKey val="0"/>
           <c:showVal val="1"/>
           <c:showCatName val="0"/>
@@ -2726,8 +2786,19 @@
         <c:scaling>
           <c:orientation val="minMax"/>
         </c:scaling>
-        <c:delete val="1"/>
+        <c:delete val="0"/>
         <c:axPos val="l"/>
+        <c:majorGridlines>
+          <c:spPr>
+            <a:ln w="6350" cap="flat">
+              <a:solidFill>
+                <a:srgbClr val="E0E0E0"/>
+              </a:solidFill>
+              <a:prstDash val="dash"/>
+              <a:round/>
+            </a:ln>
+          </c:spPr>
+        </c:majorGridlines>
         <c:numFmt formatCode="General" sourceLinked="0"/>
         <c:majorTickMark val="out"/>
         <c:minorTickMark val="none"/>
@@ -2746,11 +2817,11 @@
           <a:lstStyle/>
           <a:p>
             <a:pPr>
-              <a:defRPr sz="1200" b="0" i="0" u="none" strike="noStrike">
+              <a:defRPr sz="1000" b="0" i="0" u="none" strike="noStrike">
                 <a:solidFill>
-                  <a:srgbClr val="000000"/>
+                  <a:srgbClr val="7F7F7F"/>
                 </a:solidFill>
-                <a:latin typeface="Arial"/>
+                <a:latin typeface="Calibri"/>
               </a:defRPr>
             </a:pPr>
             <a:endParaRPr lang="en-US"/>
@@ -2826,16 +2897,15 @@
               <a:lstStyle/>
               <a:p>
                 <a:pPr>
-                  <a:defRPr b="1" i="0" strike="noStrike" sz="1100" u="none">
+                  <a:defRPr b="1" i="0" strike="noStrike" sz="1000" u="none">
                     <a:solidFill>
-                      <a:srgbClr val="FFFFFF"/>
+                      <a:srgbClr val="213366"/>
                     </a:solidFill>
                     <a:latin typeface="Calibri"/>
                   </a:defRPr>
                 </a:pPr>
               </a:p>
             </c:txPr>
-            <c:dLblPos val="inEnd"/>
             <c:showLegendKey val="0"/>
             <c:showVal val="1"/>
             <c:showCatName val="0"/>
@@ -2967,16 +3037,15 @@
             <a:lstStyle/>
             <a:p>
               <a:pPr>
-                <a:defRPr b="1" i="0" strike="noStrike" sz="1100" u="none">
+                <a:defRPr b="1" i="0" strike="noStrike" sz="1000" u="none">
                   <a:solidFill>
-                    <a:srgbClr val="FFFFFF"/>
+                    <a:srgbClr val="213366"/>
                   </a:solidFill>
                   <a:latin typeface="Calibri"/>
                 </a:defRPr>
               </a:pPr>
             </a:p>
           </c:txPr>
-          <c:dLblPos val="inEnd"/>
           <c:showLegendKey val="0"/>
           <c:showVal val="1"/>
           <c:showCatName val="0"/>
@@ -3037,8 +3106,19 @@
         <c:scaling>
           <c:orientation val="minMax"/>
         </c:scaling>
-        <c:delete val="1"/>
+        <c:delete val="0"/>
         <c:axPos val="l"/>
+        <c:majorGridlines>
+          <c:spPr>
+            <a:ln w="6350" cap="flat">
+              <a:solidFill>
+                <a:srgbClr val="E0E0E0"/>
+              </a:solidFill>
+              <a:prstDash val="dash"/>
+              <a:round/>
+            </a:ln>
+          </c:spPr>
+        </c:majorGridlines>
         <c:numFmt formatCode="General" sourceLinked="0"/>
         <c:majorTickMark val="out"/>
         <c:minorTickMark val="none"/>
@@ -3057,11 +3137,11 @@
           <a:lstStyle/>
           <a:p>
             <a:pPr>
-              <a:defRPr sz="1200" b="0" i="0" u="none" strike="noStrike">
+              <a:defRPr sz="1000" b="0" i="0" u="none" strike="noStrike">
                 <a:solidFill>
-                  <a:srgbClr val="000000"/>
+                  <a:srgbClr val="7F7F7F"/>
                 </a:solidFill>
-                <a:latin typeface="Arial"/>
+                <a:latin typeface="Calibri"/>
               </a:defRPr>
             </a:pPr>
             <a:endParaRPr lang="en-US"/>

</xml_diff>

<commit_message>
Fix PPT repair error: clean orphaned refs, fix combo chart, dual delta labels
- Added tools/clean_pptx.py to strip orphaned Content_Types (slideMaster2-5)
- Replaced broken combo chart with multi-line chart (avoids pptxgenjs XML bugs)
- X-axis labels now show BOTH Raipur and NCR deltas: "Jan'25\nR:+500 | N:-200"
- Post-process runs automatically after PPT generation
- Validated: 0 orphans, 0 XML errors, 5 slides, 4 charts

https://claude.ai/code/session_01KpPc7zotiihLV2x63w6eLV
</commit_message>
<xml_diff>
--- a/output/material_change_graphs.pptx
+++ b/output/material_change_graphs.pptx
@@ -179,67 +179,67 @@
                   </c:pt>
                   <c:pt idx="1">
                     <c:v>Jan'25
-(+700)</c:v>
+R:+700 | N:-300</c:v>
                   </c:pt>
                   <c:pt idx="2">
                     <c:v>Feb'25
-(+800)</c:v>
+R:+800 | N:+900</c:v>
                   </c:pt>
                   <c:pt idx="3">
                     <c:v>Mar'25
-(+600)</c:v>
+R:+600 | N:-500</c:v>
                   </c:pt>
                   <c:pt idx="4">
                     <c:v>Apr'25
-(-700)</c:v>
+R:-700 | N:+600</c:v>
                   </c:pt>
                   <c:pt idx="5">
                     <c:v>May'25
-(-900)</c:v>
+R:-900 | N:-1,000</c:v>
                   </c:pt>
                   <c:pt idx="6">
                     <c:v>Jun'25
-(-700)</c:v>
+R:-700 | N:-400</c:v>
                   </c:pt>
                   <c:pt idx="7">
                     <c:v>Jul'25
-(+100)</c:v>
+R:+100 | N:-500</c:v>
                   </c:pt>
                   <c:pt idx="8">
                     <c:v>Aug'25
-(+300)</c:v>
+R:+300 | N:-1,200</c:v>
                   </c:pt>
                   <c:pt idx="9">
                     <c:v>Sep'25
-(+300)</c:v>
+R:+300 | N:+700</c:v>
                   </c:pt>
                   <c:pt idx="10">
                     <c:v>Oct'25
-(-1,600)</c:v>
+R:-1,600 | N:-1,500</c:v>
                   </c:pt>
                   <c:pt idx="11">
                     <c:v>Nov'25
-(+800)</c:v>
+R:+800 | N:+1,900</c:v>
                   </c:pt>
                   <c:pt idx="12">
                     <c:v>Dec'25
-(+500)</c:v>
+R:+500 | N:-100</c:v>
                   </c:pt>
                   <c:pt idx="13">
                     <c:v>Jan'26
-(+2,250)</c:v>
+R:+2,250 | N:+2,700</c:v>
                   </c:pt>
                   <c:pt idx="14">
                     <c:v>Feb'26
-(-50)</c:v>
+R:-50 | N:-1,600</c:v>
                   </c:pt>
                   <c:pt idx="15">
                     <c:v>Mar'26
-(+800)</c:v>
+R:+800 | N:+1,700</c:v>
                   </c:pt>
                   <c:pt idx="16">
                     <c:v>Apr'26
-(+1,500)</c:v>
+R:+1,500 | N:+2,000</c:v>
                   </c:pt>
                 </c:lvl>
               </c:multiLvlStrCache>
@@ -362,67 +362,67 @@
                   </c:pt>
                   <c:pt idx="1">
                     <c:v>Jan'25
-(+700)</c:v>
+R:+700 | N:-300</c:v>
                   </c:pt>
                   <c:pt idx="2">
                     <c:v>Feb'25
-(+800)</c:v>
+R:+800 | N:+900</c:v>
                   </c:pt>
                   <c:pt idx="3">
                     <c:v>Mar'25
-(+600)</c:v>
+R:+600 | N:-500</c:v>
                   </c:pt>
                   <c:pt idx="4">
                     <c:v>Apr'25
-(-700)</c:v>
+R:-700 | N:+600</c:v>
                   </c:pt>
                   <c:pt idx="5">
                     <c:v>May'25
-(-900)</c:v>
+R:-900 | N:-1,000</c:v>
                   </c:pt>
                   <c:pt idx="6">
                     <c:v>Jun'25
-(-700)</c:v>
+R:-700 | N:-400</c:v>
                   </c:pt>
                   <c:pt idx="7">
                     <c:v>Jul'25
-(+100)</c:v>
+R:+100 | N:-500</c:v>
                   </c:pt>
                   <c:pt idx="8">
                     <c:v>Aug'25
-(+300)</c:v>
+R:+300 | N:-1,200</c:v>
                   </c:pt>
                   <c:pt idx="9">
                     <c:v>Sep'25
-(+300)</c:v>
+R:+300 | N:+700</c:v>
                   </c:pt>
                   <c:pt idx="10">
                     <c:v>Oct'25
-(-1,600)</c:v>
+R:-1,600 | N:-1,500</c:v>
                   </c:pt>
                   <c:pt idx="11">
                     <c:v>Nov'25
-(+800)</c:v>
+R:+800 | N:+1,900</c:v>
                   </c:pt>
                   <c:pt idx="12">
                     <c:v>Dec'25
-(+500)</c:v>
+R:+500 | N:-100</c:v>
                   </c:pt>
                   <c:pt idx="13">
                     <c:v>Jan'26
-(+2,250)</c:v>
+R:+2,250 | N:+2,700</c:v>
                   </c:pt>
                   <c:pt idx="14">
                     <c:v>Feb'26
-(-50)</c:v>
+R:-50 | N:-1,600</c:v>
                   </c:pt>
                   <c:pt idx="15">
                     <c:v>Mar'26
-(+800)</c:v>
+R:+800 | N:+1,700</c:v>
                   </c:pt>
                   <c:pt idx="16">
                     <c:v>Apr'26
-(+1,500)</c:v>
+R:+1,500 | N:+2,000</c:v>
                   </c:pt>
                 </c:lvl>
               </c:multiLvlStrCache>
@@ -664,9 +664,7 @@
     <c:autoTitleDeleted val="1"/>
     <c:plotArea>
       <c:layout/>
-      <c:barChart>
-        <c:barDir val="col"/>
-        <c:grouping val="clustered"/>
+      <c:lineChart>
         <c:varyColors val="0"/>
         <c:ser>
           <c:idx val="0"/>
@@ -686,6 +684,13 @@
             <a:solidFill>
               <a:srgbClr val="1565C0"/>
             </a:solidFill>
+            <a:ln w="25400" cap="flat">
+              <a:solidFill>
+                <a:srgbClr val="1565C0"/>
+              </a:solidFill>
+              <a:prstDash val="solid"/>
+              <a:round/>
+            </a:ln>
             <a:effectLst/>
           </c:spPr>
           <c:invertIfNegative val="0"/>
@@ -713,6 +718,23 @@
             <c:showBubbleSize val="0"/>
             <c:showLeaderLines val="0"/>
           </c:dLbls>
+          <c:marker>
+            <c:symbol val="circle"/>
+            <c:size val="6"/>
+            <c:spPr>
+              <a:solidFill>
+                <a:srgbClr val="1565C0"/>
+              </a:solidFill>
+              <a:ln w="9525" cap="flat">
+                <a:solidFill>
+                  <a:srgbClr val="1565C0"/>
+                </a:solidFill>
+                <a:prstDash val="solid"/>
+                <a:round/>
+              </a:ln>
+              <a:effectLst/>
+            </c:spPr>
+          </c:marker>
           <c:cat>
             <c:multiLvlStrRef>
               <c:f>Sheet1!$A$2:$A$18</c:f>
@@ -834,6 +856,7 @@
               </c:numCache>
             </c:numRef>
           </c:val>
+          <c:smooth val="0"/>
         </c:ser>
         <c:ser>
           <c:idx val="1"/>
@@ -853,6 +876,13 @@
             <a:solidFill>
               <a:srgbClr val="D32F2F"/>
             </a:solidFill>
+            <a:ln w="25400" cap="flat">
+              <a:solidFill>
+                <a:srgbClr val="D32F2F"/>
+              </a:solidFill>
+              <a:prstDash val="solid"/>
+              <a:round/>
+            </a:ln>
             <a:effectLst/>
           </c:spPr>
           <c:invertIfNegative val="0"/>
@@ -880,6 +910,23 @@
             <c:showBubbleSize val="0"/>
             <c:showLeaderLines val="0"/>
           </c:dLbls>
+          <c:marker>
+            <c:symbol val="circle"/>
+            <c:size val="6"/>
+            <c:spPr>
+              <a:solidFill>
+                <a:srgbClr val="D32F2F"/>
+              </a:solidFill>
+              <a:ln w="9525" cap="flat">
+                <a:solidFill>
+                  <a:srgbClr val="D32F2F"/>
+                </a:solidFill>
+                <a:prstDash val="solid"/>
+                <a:round/>
+              </a:ln>
+              <a:effectLst/>
+            </c:spPr>
+          </c:marker>
           <c:cat>
             <c:multiLvlStrRef>
               <c:f>Sheet1!$A$2:$A$18</c:f>
@@ -1001,6 +1048,7 @@
               </c:numCache>
             </c:numRef>
           </c:val>
+          <c:smooth val="0"/>
         </c:ser>
         <c:ser>
           <c:idx val="2"/>
@@ -1020,6 +1068,13 @@
             <a:solidFill>
               <a:srgbClr val="616161"/>
             </a:solidFill>
+            <a:ln w="25400" cap="flat">
+              <a:solidFill>
+                <a:srgbClr val="616161"/>
+              </a:solidFill>
+              <a:prstDash val="solid"/>
+              <a:round/>
+            </a:ln>
             <a:effectLst/>
           </c:spPr>
           <c:invertIfNegative val="0"/>
@@ -1047,6 +1102,23 @@
             <c:showBubbleSize val="0"/>
             <c:showLeaderLines val="0"/>
           </c:dLbls>
+          <c:marker>
+            <c:symbol val="circle"/>
+            <c:size val="6"/>
+            <c:spPr>
+              <a:solidFill>
+                <a:srgbClr val="616161"/>
+              </a:solidFill>
+              <a:ln w="9525" cap="flat">
+                <a:solidFill>
+                  <a:srgbClr val="616161"/>
+                </a:solidFill>
+                <a:prstDash val="solid"/>
+                <a:round/>
+              </a:ln>
+              <a:effectLst/>
+            </c:spPr>
+          </c:marker>
           <c:cat>
             <c:multiLvlStrRef>
               <c:f>Sheet1!$A$2:$A$18</c:f>
@@ -1168,39 +1240,8 @@
               </c:numCache>
             </c:numRef>
           </c:val>
+          <c:smooth val="0"/>
         </c:ser>
-        <c:dLbls>
-          <c:numFmt formatCode="#,##0" sourceLinked="0"/>
-          <c:txPr>
-            <a:bodyPr/>
-            <a:lstStyle/>
-            <a:p>
-              <a:pPr>
-                <a:defRPr b="0" i="0" strike="noStrike" sz="1200" u="none">
-                  <a:solidFill>
-                    <a:srgbClr val="000000"/>
-                  </a:solidFill>
-                  <a:latin typeface="Arial"/>
-                </a:defRPr>
-              </a:pPr>
-            </a:p>
-          </c:txPr>
-          <c:showLegendKey val="0"/>
-          <c:showVal val="0"/>
-          <c:showCatName val="0"/>
-          <c:showSerName val="0"/>
-          <c:showPercent val="0"/>
-          <c:showBubbleSize val="0"/>
-          <c:showLeaderLines val="0"/>
-        </c:dLbls>
-        <c:gapWidth val="150"/>
-        <c:overlap val="0"/>
-        <c:axId val="2094734554"/>
-        <c:axId val="2094734553"/>
-        <c:axId val="2094734556"/>
-      </c:barChart>
-      <c:lineChart>
-        <c:varyColors val="0"/>
         <c:ser>
           <c:idx val="3"/>
           <c:order val="3"/>
@@ -1219,7 +1260,7 @@
             <a:solidFill>
               <a:srgbClr val="FF8F00"/>
             </a:solidFill>
-            <a:ln w="31750" cap="flat">
+            <a:ln w="25400" cap="flat">
               <a:solidFill>
                 <a:srgbClr val="FF8F00"/>
               </a:solidFill>
@@ -1419,7 +1460,7 @@
         </c:dLbls>
         <c:marker val="1"/>
         <c:axId val="2094734554"/>
-        <c:axId val="2094734553"/>
+        <c:axId val="2094734552"/>
         <c:axId val="2094734556"/>
       </c:lineChart>
       <c:catAx>
@@ -1627,67 +1668,67 @@
                   </c:pt>
                   <c:pt idx="1">
                     <c:v>Jan'25
-(+97)</c:v>
+R:+97 | N:+263</c:v>
                   </c:pt>
                   <c:pt idx="2">
                     <c:v>Feb'25
-(-409)</c:v>
+R:-409 | N:-178</c:v>
                   </c:pt>
                   <c:pt idx="3">
                     <c:v>Mar'25
-(+220)</c:v>
+R:+220 | N:-523</c:v>
                   </c:pt>
                   <c:pt idx="4">
                     <c:v>Apr'25
-(+1,186)</c:v>
+R:+1,186 | N:+522</c:v>
                   </c:pt>
                   <c:pt idx="5">
                     <c:v>May'25
-(-154)</c:v>
+R:-154 | N:+149</c:v>
                   </c:pt>
                   <c:pt idx="6">
                     <c:v>Jun'25
-(-556)</c:v>
+R:-556 | N:+227</c:v>
                   </c:pt>
                   <c:pt idx="7">
                     <c:v>Jul'25
-(-2,075)</c:v>
+R:-2,075 | N:-1,465</c:v>
                   </c:pt>
                   <c:pt idx="8">
                     <c:v>Aug'25
-(+687)</c:v>
+R:+687 | N:+310</c:v>
                   </c:pt>
                   <c:pt idx="9">
                     <c:v>Sep'25
-(-1,291)</c:v>
+R:-1,291 | N:-467</c:v>
                   </c:pt>
                   <c:pt idx="10">
                     <c:v>Oct'25
-(+343)</c:v>
+R:+343 | N:+207</c:v>
                   </c:pt>
                   <c:pt idx="11">
                     <c:v>Nov'25
-(+244)</c:v>
+R:+244 | N:+256</c:v>
                   </c:pt>
                   <c:pt idx="12">
                     <c:v>Dec'25
-(+1,808)</c:v>
+R:+1,808 | N:+543</c:v>
                   </c:pt>
                   <c:pt idx="13">
                     <c:v>Jan'26
-(-185)</c:v>
+R:-185 | N:+812</c:v>
                   </c:pt>
                   <c:pt idx="14">
                     <c:v>Feb'26
-(-1,044)</c:v>
+R:-1,044 | N:-847</c:v>
                   </c:pt>
                   <c:pt idx="15">
                     <c:v>Mar'26
-(+1,121)</c:v>
+R:+1,121 | N:+278</c:v>
                   </c:pt>
                   <c:pt idx="16">
                     <c:v>Apr'26
-(-93)</c:v>
+R:-93 | N:-80</c:v>
                   </c:pt>
                 </c:lvl>
               </c:multiLvlStrCache>
@@ -1810,67 +1851,67 @@
                   </c:pt>
                   <c:pt idx="1">
                     <c:v>Jan'25
-(+97)</c:v>
+R:+97 | N:+263</c:v>
                   </c:pt>
                   <c:pt idx="2">
                     <c:v>Feb'25
-(-409)</c:v>
+R:-409 | N:-178</c:v>
                   </c:pt>
                   <c:pt idx="3">
                     <c:v>Mar'25
-(+220)</c:v>
+R:+220 | N:-523</c:v>
                   </c:pt>
                   <c:pt idx="4">
                     <c:v>Apr'25
-(+1,186)</c:v>
+R:+1,186 | N:+522</c:v>
                   </c:pt>
                   <c:pt idx="5">
                     <c:v>May'25
-(-154)</c:v>
+R:-154 | N:+149</c:v>
                   </c:pt>
                   <c:pt idx="6">
                     <c:v>Jun'25
-(-556)</c:v>
+R:-556 | N:+227</c:v>
                   </c:pt>
                   <c:pt idx="7">
                     <c:v>Jul'25
-(-2,075)</c:v>
+R:-2,075 | N:-1,465</c:v>
                   </c:pt>
                   <c:pt idx="8">
                     <c:v>Aug'25
-(+687)</c:v>
+R:+687 | N:+310</c:v>
                   </c:pt>
                   <c:pt idx="9">
                     <c:v>Sep'25
-(-1,291)</c:v>
+R:-1,291 | N:-467</c:v>
                   </c:pt>
                   <c:pt idx="10">
                     <c:v>Oct'25
-(+343)</c:v>
+R:+343 | N:+207</c:v>
                   </c:pt>
                   <c:pt idx="11">
                     <c:v>Nov'25
-(+244)</c:v>
+R:+244 | N:+256</c:v>
                   </c:pt>
                   <c:pt idx="12">
                     <c:v>Dec'25
-(+1,808)</c:v>
+R:+1,808 | N:+543</c:v>
                   </c:pt>
                   <c:pt idx="13">
                     <c:v>Jan'26
-(-185)</c:v>
+R:-185 | N:+812</c:v>
                   </c:pt>
                   <c:pt idx="14">
                     <c:v>Feb'26
-(-1,044)</c:v>
+R:-1,044 | N:-847</c:v>
                   </c:pt>
                   <c:pt idx="15">
                     <c:v>Mar'26
-(+1,121)</c:v>
+R:+1,121 | N:+278</c:v>
                   </c:pt>
                   <c:pt idx="16">
                     <c:v>Apr'26
-(-93)</c:v>
+R:-93 | N:-80</c:v>
                   </c:pt>
                 </c:lvl>
               </c:multiLvlStrCache>
@@ -2172,67 +2213,67 @@
                   </c:pt>
                   <c:pt idx="1">
                     <c:v>Jan'25
-(-153)</c:v>
+R:-153 | N:-135</c:v>
                   </c:pt>
                   <c:pt idx="2">
                     <c:v>Feb'25
-(-267)</c:v>
+R:-267 | N:+114</c:v>
                   </c:pt>
                   <c:pt idx="3">
                     <c:v>Mar'25
-(+965)</c:v>
+R:+965 | N:+975</c:v>
                   </c:pt>
                   <c:pt idx="4">
                     <c:v>Apr'25
-(+1,891)</c:v>
+R:+1,891 | N:+872</c:v>
                   </c:pt>
                   <c:pt idx="5">
                     <c:v>May'25
-(-994)</c:v>
+R:-994 | N:-791</c:v>
                   </c:pt>
                   <c:pt idx="6">
                     <c:v>Jun'25
-(-644)</c:v>
+R:-644 | N:-166</c:v>
                   </c:pt>
                   <c:pt idx="7">
                     <c:v>Jul'25
-(-2,746)</c:v>
+R:-2,746 | N:-1,073</c:v>
                   </c:pt>
                   <c:pt idx="8">
                     <c:v>Aug'25
-(+900)</c:v>
+R:+900 | N:-778</c:v>
                   </c:pt>
                   <c:pt idx="9">
                     <c:v>Sep'25
-(-1,149)</c:v>
+R:-1,149 | N:-474</c:v>
                   </c:pt>
                   <c:pt idx="10">
                     <c:v>Oct'25
-(-143)</c:v>
+R:-143 | N:-580</c:v>
                   </c:pt>
                   <c:pt idx="11">
                     <c:v>Nov'25
-(+436)</c:v>
+R:+436 | N:+294</c:v>
                   </c:pt>
                   <c:pt idx="12">
                     <c:v>Dec'25
-(+1,713)</c:v>
+R:+1,713 | N:+1,196</c:v>
                   </c:pt>
                   <c:pt idx="13">
                     <c:v>Jan'26
-(+536)</c:v>
+R:+536 | N:+1,584</c:v>
                   </c:pt>
                   <c:pt idx="14">
                     <c:v>Feb'26
-(-594)</c:v>
+R:-594 | N:+559</c:v>
                   </c:pt>
                   <c:pt idx="15">
                     <c:v>Mar'26
-(+1,920)</c:v>
+R:+1,920 | N:+1,472</c:v>
                   </c:pt>
                   <c:pt idx="16">
                     <c:v>Apr'26
-(+591)</c:v>
+R:+591 | N:+554</c:v>
                   </c:pt>
                 </c:lvl>
               </c:multiLvlStrCache>
@@ -2355,67 +2396,67 @@
                   </c:pt>
                   <c:pt idx="1">
                     <c:v>Jan'25
-(-153)</c:v>
+R:-153 | N:-135</c:v>
                   </c:pt>
                   <c:pt idx="2">
                     <c:v>Feb'25
-(-267)</c:v>
+R:-267 | N:+114</c:v>
                   </c:pt>
                   <c:pt idx="3">
                     <c:v>Mar'25
-(+965)</c:v>
+R:+965 | N:+975</c:v>
                   </c:pt>
                   <c:pt idx="4">
                     <c:v>Apr'25
-(+1,891)</c:v>
+R:+1,891 | N:+872</c:v>
                   </c:pt>
                   <c:pt idx="5">
                     <c:v>May'25
-(-994)</c:v>
+R:-994 | N:-791</c:v>
                   </c:pt>
                   <c:pt idx="6">
                     <c:v>Jun'25
-(-644)</c:v>
+R:-644 | N:-166</c:v>
                   </c:pt>
                   <c:pt idx="7">
                     <c:v>Jul'25
-(-2,746)</c:v>
+R:-2,746 | N:-1,073</c:v>
                   </c:pt>
                   <c:pt idx="8">
                     <c:v>Aug'25
-(+900)</c:v>
+R:+900 | N:-778</c:v>
                   </c:pt>
                   <c:pt idx="9">
                     <c:v>Sep'25
-(-1,149)</c:v>
+R:-1,149 | N:-474</c:v>
                   </c:pt>
                   <c:pt idx="10">
                     <c:v>Oct'25
-(-143)</c:v>
+R:-143 | N:-580</c:v>
                   </c:pt>
                   <c:pt idx="11">
                     <c:v>Nov'25
-(+436)</c:v>
+R:+436 | N:+294</c:v>
                   </c:pt>
                   <c:pt idx="12">
                     <c:v>Dec'25
-(+1,713)</c:v>
+R:+1,713 | N:+1,196</c:v>
                   </c:pt>
                   <c:pt idx="13">
                     <c:v>Jan'26
-(+536)</c:v>
+R:+536 | N:+1,584</c:v>
                   </c:pt>
                   <c:pt idx="14">
                     <c:v>Feb'26
-(-594)</c:v>
+R:-594 | N:+559</c:v>
                   </c:pt>
                   <c:pt idx="15">
                     <c:v>Mar'26
-(+1,920)</c:v>
+R:+1,920 | N:+1,472</c:v>
                   </c:pt>
                   <c:pt idx="16">
                     <c:v>Apr'26
-(+591)</c:v>
+R:+591 | N:+554</c:v>
                   </c:pt>
                 </c:lvl>
               </c:multiLvlStrCache>
@@ -4521,7 +4562,7 @@
                 <a:ea typeface="Calibri" pitchFamily="34" charset="-122"/>
                 <a:cs typeface="Calibri" pitchFamily="34" charset="-120"/>
               </a:rPr>
-              <a:t>Latest change:  Pallet DRI: +1,600 INR/MT  |  Pig Iron: +1,500 INR/MT  |  Iron Ore DRI: +1,750 INR/MT  |  Silico Manganese: +5.5 INR/kg</a:t>
+              <a:t>Latest change:  Pallet DRI: +1,600 INR/MT  |  Pig Iron: +1,500 INR/MT  |  Iron Ore DRI: +1,750 INR/MT  |  Silico Manganese: +5.5 INR/kg  •  Note: Silico Mn values in INR/kg (others in INR/MT)</a:t>
             </a:r>
             <a:endParaRPr lang="en-US" sz="1100" dirty="0"/>
           </a:p>

</xml_diff>

<commit_message>
Fix Silico Mn chart: scale ×400 so it plots visibly with INR/MT materials
Silico Mn (65-81 INR/kg) was invisible against INR/MT values (22k-38k).
Now scaled by ×400 to align visually. Legend shows "Silico Manganese (INR/kg × 400)".
All 4 materials now visible on the same chart in the 22k-38k range.

https://claude.ai/code/session_01KpPc7zotiihLV2x63w6eLV
</commit_message>
<xml_diff>
--- a/output/material_change_graphs.pptx
+++ b/output/material_change_graphs.pptx
@@ -1251,7 +1251,7 @@
               <c:strCache>
                 <c:ptCount val="1"/>
                 <c:pt idx="0">
-                  <c:v>Silico Manganese</c:v>
+                  <c:v>Silico Manganese (INR/kg × 400)</c:v>
                 </c:pt>
               </c:strCache>
             </c:strRef>
@@ -1379,55 +1379,55 @@
                 <c:formatCode>General</c:formatCode>
                 <c:ptCount val="17"/>
                 <c:pt idx="0">
-                  <c:v>65.5</c:v>
+                  <c:v>26200</c:v>
                 </c:pt>
                 <c:pt idx="1">
-                  <c:v>69.8</c:v>
+                  <c:v>27920</c:v>
                 </c:pt>
                 <c:pt idx="2">
-                  <c:v>71.4</c:v>
+                  <c:v>28560.000000000004</c:v>
                 </c:pt>
                 <c:pt idx="3">
-                  <c:v>73</c:v>
+                  <c:v>29200</c:v>
                 </c:pt>
                 <c:pt idx="4">
-                  <c:v>70.8</c:v>
+                  <c:v>28320</c:v>
                 </c:pt>
                 <c:pt idx="5">
-                  <c:v>72.2</c:v>
+                  <c:v>28880</c:v>
                 </c:pt>
                 <c:pt idx="6">
-                  <c:v>72.3</c:v>
+                  <c:v>28920</c:v>
                 </c:pt>
                 <c:pt idx="7">
-                  <c:v>72.3</c:v>
+                  <c:v>28920</c:v>
                 </c:pt>
                 <c:pt idx="8">
-                  <c:v>69.9</c:v>
+                  <c:v>27960.000000000004</c:v>
                 </c:pt>
                 <c:pt idx="9">
-                  <c:v>69.9</c:v>
+                  <c:v>27960.000000000004</c:v>
                 </c:pt>
                 <c:pt idx="10">
-                  <c:v>72</c:v>
+                  <c:v>28800</c:v>
                 </c:pt>
                 <c:pt idx="11">
-                  <c:v>69.9</c:v>
+                  <c:v>27960.000000000004</c:v>
                 </c:pt>
                 <c:pt idx="12">
-                  <c:v>69.3</c:v>
+                  <c:v>27720</c:v>
                 </c:pt>
                 <c:pt idx="13">
-                  <c:v>73.1</c:v>
+                  <c:v>29239.999999999996</c:v>
                 </c:pt>
                 <c:pt idx="14">
-                  <c:v>73.2</c:v>
+                  <c:v>29280</c:v>
                 </c:pt>
                 <c:pt idx="15">
-                  <c:v>75.5</c:v>
+                  <c:v>30200</c:v>
                 </c:pt>
                 <c:pt idx="16">
-                  <c:v>81</c:v>
+                  <c:v>32400</c:v>
                 </c:pt>
               </c:numCache>
             </c:numRef>
@@ -4408,7 +4408,7 @@
                 <a:ea typeface="Calibri" pitchFamily="34" charset="-122"/>
                 <a:cs typeface="Calibri" pitchFamily="34" charset="-120"/>
               </a:rPr>
-              <a:t>Raw Materials — Raipur — INR/MT / INR/kg</a:t>
+              <a:t>Raw Materials — Raipur — INR/MT</a:t>
             </a:r>
             <a:endParaRPr lang="en-US" sz="2000" dirty="0"/>
           </a:p>
@@ -4562,7 +4562,7 @@
                 <a:ea typeface="Calibri" pitchFamily="34" charset="-122"/>
                 <a:cs typeface="Calibri" pitchFamily="34" charset="-120"/>
               </a:rPr>
-              <a:t>Latest change:  Pallet DRI: +1,600 INR/MT  |  Pig Iron: +1,500 INR/MT  |  Iron Ore DRI: +1,750 INR/MT  |  Silico Manganese: +5.5 INR/kg  •  Note: Silico Mn values in INR/kg (others in INR/MT)</a:t>
+              <a:t>Latest change:  Pallet DRI: +1,600 INR/MT  |  Pig Iron: +1,500 INR/MT  |  Iron Ore DRI: +1,750 INR/MT  |  Silico Manganese: +5.5 INR/kg</a:t>
             </a:r>
             <a:endParaRPr lang="en-US" sz="1100" dirty="0"/>
           </a:p>

</xml_diff>

<commit_message>
Update material change graphs for 2026-04-10
</commit_message>
<xml_diff>
--- a/output/material_change_graphs.pptx
+++ b/output/material_change_graphs.pptx
@@ -239,7 +239,7 @@
                   </c:pt>
                   <c:pt idx="16">
                     <c:v>Apr'26
-R:+1,500 | N:+2,000</c:v>
+R:+1,800 | N:+2,800</c:v>
                   </c:pt>
                 </c:lvl>
               </c:multiLvlStrCache>
@@ -300,7 +300,7 @@
                   <c:v>34500</c:v>
                 </c:pt>
                 <c:pt idx="16">
-                  <c:v>36000</c:v>
+                  <c:v>36300</c:v>
                 </c:pt>
               </c:numCache>
             </c:numRef>
@@ -422,7 +422,7 @@
                   </c:pt>
                   <c:pt idx="16">
                     <c:v>Apr'26
-R:+1,500 | N:+2,000</c:v>
+R:+1,800 | N:+2,800</c:v>
                   </c:pt>
                 </c:lvl>
               </c:multiLvlStrCache>
@@ -483,7 +483,7 @@
                   <c:v>34500</c:v>
                 </c:pt>
                 <c:pt idx="16">
-                  <c:v>36500</c:v>
+                  <c:v>37300</c:v>
                 </c:pt>
               </c:numCache>
             </c:numRef>
@@ -851,7 +851,7 @@
                   <c:v>25800</c:v>
                 </c:pt>
                 <c:pt idx="16">
-                  <c:v>27400</c:v>
+                  <c:v>27050</c:v>
                 </c:pt>
               </c:numCache>
             </c:numRef>
@@ -1043,7 +1043,7 @@
                   <c:v>37050</c:v>
                 </c:pt>
                 <c:pt idx="16">
-                  <c:v>38550</c:v>
+                  <c:v>39700</c:v>
                 </c:pt>
               </c:numCache>
             </c:numRef>
@@ -1235,7 +1235,7 @@
                   <c:v>29650</c:v>
                 </c:pt>
                 <c:pt idx="16">
-                  <c:v>31400</c:v>
+                  <c:v>31000</c:v>
                 </c:pt>
               </c:numCache>
             </c:numRef>
@@ -1427,7 +1427,7 @@
                   <c:v>30200</c:v>
                 </c:pt>
                 <c:pt idx="16">
-                  <c:v>32400</c:v>
+                  <c:v>34840</c:v>
                 </c:pt>
               </c:numCache>
             </c:numRef>
@@ -1728,7 +1728,7 @@
                   </c:pt>
                   <c:pt idx="16">
                     <c:v>Apr'26
-R:-93 | N:-80</c:v>
+R:+239 | N:+340</c:v>
                   </c:pt>
                 </c:lvl>
               </c:multiLvlStrCache>
@@ -1789,7 +1789,7 @@
                   <c:v>509.7</c:v>
                 </c:pt>
                 <c:pt idx="16">
-                  <c:v>416.63</c:v>
+                  <c:v>748.29</c:v>
                 </c:pt>
               </c:numCache>
             </c:numRef>
@@ -1911,7 +1911,7 @@
                   </c:pt>
                   <c:pt idx="16">
                     <c:v>Apr'26
-R:-93 | N:-80</c:v>
+R:+239 | N:+340</c:v>
                   </c:pt>
                 </c:lvl>
               </c:multiLvlStrCache>
@@ -1972,7 +1972,7 @@
                   <c:v>172.45</c:v>
                 </c:pt>
                 <c:pt idx="16">
-                  <c:v>92.68</c:v>
+                  <c:v>512.16</c:v>
                 </c:pt>
               </c:numCache>
             </c:numRef>
@@ -2273,7 +2273,7 @@
                   </c:pt>
                   <c:pt idx="16">
                     <c:v>Apr'26
-R:+591 | N:+554</c:v>
+R:+273 | N:+669</c:v>
                   </c:pt>
                 </c:lvl>
               </c:multiLvlStrCache>
@@ -2334,7 +2334,7 @@
                   <c:v>2456.18</c:v>
                 </c:pt>
                 <c:pt idx="16">
-                  <c:v>3047.16</c:v>
+                  <c:v>2729.48</c:v>
                 </c:pt>
               </c:numCache>
             </c:numRef>
@@ -2456,7 +2456,7 @@
                   </c:pt>
                   <c:pt idx="16">
                     <c:v>Apr'26
-R:+591 | N:+554</c:v>
+R:+273 | N:+669</c:v>
                   </c:pt>
                 </c:lvl>
               </c:multiLvlStrCache>
@@ -2517,7 +2517,7 @@
                   <c:v>4245.83</c:v>
                 </c:pt>
                 <c:pt idx="16">
-                  <c:v>4799.42</c:v>
+                  <c:v>4915.05</c:v>
                 </c:pt>
               </c:numCache>
             </c:numRef>
@@ -3995,7 +3995,7 @@
                 <a:ea typeface="Calibri" pitchFamily="34" charset="-122"/>
                 <a:cs typeface="Calibri" pitchFamily="34" charset="-120"/>
               </a:rPr>
-              <a:t>Period: 2024-12-12 to 2026-04-02  |  17 months</a:t>
+              <a:t>Period: 2024-12-12 to 2026-04-10  |  17 months</a:t>
             </a:r>
             <a:endParaRPr lang="en-US" sz="1200" dirty="0"/>
           </a:p>
@@ -4259,7 +4259,7 @@
                 <a:ea typeface="Calibri" pitchFamily="34" charset="-122"/>
                 <a:cs typeface="Calibri" pitchFamily="34" charset="-120"/>
               </a:rPr>
-              <a:t>Latest:  Raipur +1,500  |  NCR +2,000     •     Avg:  Raipur 32,368  |  NCR 32,788 INR/MT</a:t>
+              <a:t>Latest:  Raipur +1,800  |  NCR +2,800     •     Avg:  Raipur 32,385  |  NCR 32,835 INR/MT</a:t>
             </a:r>
             <a:endParaRPr lang="en-US" sz="1100" dirty="0"/>
           </a:p>
@@ -4562,7 +4562,7 @@
                 <a:ea typeface="Calibri" pitchFamily="34" charset="-122"/>
                 <a:cs typeface="Calibri" pitchFamily="34" charset="-120"/>
               </a:rPr>
-              <a:t>Latest change:  Pallet DRI: +1,600 INR/MT  |  Pig Iron: +1,500 INR/MT  |  Iron Ore DRI: +1,750 INR/MT  |  Silico Manganese: +5.5 INR/kg</a:t>
+              <a:t>Latest change:  Pallet DRI: +1,250 INR/MT  |  Pig Iron: +2,650 INR/MT  |  Iron Ore DRI: +1,350 INR/MT  |  Silico Manganese: +11.6 INR/kg</a:t>
             </a:r>
             <a:endParaRPr lang="en-US" sz="1100" dirty="0"/>
           </a:p>
@@ -4865,7 +4865,7 @@
                 <a:ea typeface="Calibri" pitchFamily="34" charset="-122"/>
                 <a:cs typeface="Calibri" pitchFamily="34" charset="-120"/>
               </a:rPr>
-              <a:t>Latest:  Raipur -93  |  NCR -80     •     Avg:  Raipur 62  |  NCR -116 INR/MT</a:t>
+              <a:t>Latest:  Raipur +239  |  NCR +340     •     Avg:  Raipur 81  |  NCR -91 INR/MT</a:t>
             </a:r>
             <a:endParaRPr lang="en-US" sz="1100" dirty="0"/>
           </a:p>
@@ -5168,7 +5168,7 @@
                 <a:ea typeface="Calibri" pitchFamily="34" charset="-122"/>
                 <a:cs typeface="Calibri" pitchFamily="34" charset="-120"/>
               </a:rPr>
-              <a:t>Latest:  Raipur +591  |  NCR +554     •     Avg:  Raipur 729  |  NCR 1,582 INR/MT</a:t>
+              <a:t>Latest:  Raipur +273  |  NCR +669     •     Avg:  Raipur 711  |  NCR 1,589 INR/MT</a:t>
             </a:r>
             <a:endParaRPr lang="en-US" sz="1100" dirty="0"/>
           </a:p>

</xml_diff>

<commit_message>
Regenerate material change graphs for Apr-May 2026
https://claude.ai/code/session_01LspGJUfGjErh26cEybjfCX
</commit_message>
<xml_diff>
--- a/output/material_change_graphs.pptx
+++ b/output/material_change_graphs.pptx
@@ -170,9 +170,9 @@
           </c:dLbls>
           <c:cat>
             <c:multiLvlStrRef>
-              <c:f>Sheet1!$A$2:$A$18</c:f>
+              <c:f>Sheet1!$A$2:$A$19</c:f>
               <c:multiLvlStrCache>
-                <c:ptCount val="17"/>
+                <c:ptCount val="18"/>
                 <c:lvl>
                   <c:pt idx="0">
                     <c:v>Dec'24</c:v>
@@ -239,7 +239,11 @@
                   </c:pt>
                   <c:pt idx="16">
                     <c:v>Apr'26
-R:+1,800 | N:+2,800</c:v>
+R:+1,100 | N:+1,300</c:v>
+                  </c:pt>
+                  <c:pt idx="17">
+                    <c:v>May'26
+R:-1,100 | N:-1,600</c:v>
                   </c:pt>
                 </c:lvl>
               </c:multiLvlStrCache>
@@ -247,10 +251,10 @@
           </c:cat>
           <c:val>
             <c:numRef>
-              <c:f>Sheet1!$B$2:$B$18</c:f>
+              <c:f>Sheet1!$B$2:$B$19</c:f>
               <c:numCache>
                 <c:formatCode>General</c:formatCode>
-                <c:ptCount val="17"/>
+                <c:ptCount val="18"/>
                 <c:pt idx="0">
                   <c:v>31300</c:v>
                 </c:pt>
@@ -300,7 +304,10 @@
                   <c:v>34500</c:v>
                 </c:pt>
                 <c:pt idx="16">
-                  <c:v>36300</c:v>
+                  <c:v>35600</c:v>
+                </c:pt>
+                <c:pt idx="17">
+                  <c:v>34500</c:v>
                 </c:pt>
               </c:numCache>
             </c:numRef>
@@ -353,9 +360,9 @@
           </c:dLbls>
           <c:cat>
             <c:multiLvlStrRef>
-              <c:f>Sheet1!$A$2:$A$18</c:f>
+              <c:f>Sheet1!$A$2:$A$19</c:f>
               <c:multiLvlStrCache>
-                <c:ptCount val="17"/>
+                <c:ptCount val="18"/>
                 <c:lvl>
                   <c:pt idx="0">
                     <c:v>Dec'24</c:v>
@@ -422,7 +429,11 @@
                   </c:pt>
                   <c:pt idx="16">
                     <c:v>Apr'26
-R:+1,800 | N:+2,800</c:v>
+R:+1,100 | N:+1,300</c:v>
+                  </c:pt>
+                  <c:pt idx="17">
+                    <c:v>May'26
+R:-1,100 | N:-1,600</c:v>
                   </c:pt>
                 </c:lvl>
               </c:multiLvlStrCache>
@@ -430,10 +441,10 @@
           </c:cat>
           <c:val>
             <c:numRef>
-              <c:f>Sheet1!$C$2:$C$18</c:f>
+              <c:f>Sheet1!$C$2:$C$19</c:f>
               <c:numCache>
                 <c:formatCode>General</c:formatCode>
-                <c:ptCount val="17"/>
+                <c:ptCount val="18"/>
                 <c:pt idx="0">
                   <c:v>33100</c:v>
                 </c:pt>
@@ -483,7 +494,10 @@
                   <c:v>34500</c:v>
                 </c:pt>
                 <c:pt idx="16">
-                  <c:v>37300</c:v>
+                  <c:v>35800</c:v>
+                </c:pt>
+                <c:pt idx="17">
+                  <c:v>34200</c:v>
                 </c:pt>
               </c:numCache>
             </c:numRef>
@@ -737,9 +751,9 @@
           </c:marker>
           <c:cat>
             <c:multiLvlStrRef>
-              <c:f>Sheet1!$A$2:$A$18</c:f>
+              <c:f>Sheet1!$A$2:$A$19</c:f>
               <c:multiLvlStrCache>
-                <c:ptCount val="17"/>
+                <c:ptCount val="18"/>
                 <c:lvl>
                   <c:pt idx="0">
                     <c:v>Dec'24</c:v>
@@ -791,6 +805,9 @@
                   </c:pt>
                   <c:pt idx="16">
                     <c:v>Apr'26</c:v>
+                  </c:pt>
+                  <c:pt idx="17">
+                    <c:v>May'26</c:v>
                   </c:pt>
                 </c:lvl>
               </c:multiLvlStrCache>
@@ -798,10 +815,10 @@
           </c:cat>
           <c:val>
             <c:numRef>
-              <c:f>Sheet1!$B$2:$B$18</c:f>
+              <c:f>Sheet1!$B$2:$B$19</c:f>
               <c:numCache>
                 <c:formatCode>General</c:formatCode>
-                <c:ptCount val="17"/>
+                <c:ptCount val="18"/>
                 <c:pt idx="0">
                   <c:v>24200</c:v>
                 </c:pt>
@@ -851,7 +868,10 @@
                   <c:v>25800</c:v>
                 </c:pt>
                 <c:pt idx="16">
-                  <c:v>27050</c:v>
+                  <c:v>25550</c:v>
+                </c:pt>
+                <c:pt idx="17">
+                  <c:v>25000</c:v>
                 </c:pt>
               </c:numCache>
             </c:numRef>
@@ -929,9 +949,9 @@
           </c:marker>
           <c:cat>
             <c:multiLvlStrRef>
-              <c:f>Sheet1!$A$2:$A$18</c:f>
+              <c:f>Sheet1!$A$2:$A$19</c:f>
               <c:multiLvlStrCache>
-                <c:ptCount val="17"/>
+                <c:ptCount val="18"/>
                 <c:lvl>
                   <c:pt idx="0">
                     <c:v>Dec'24</c:v>
@@ -983,6 +1003,9 @@
                   </c:pt>
                   <c:pt idx="16">
                     <c:v>Apr'26</c:v>
+                  </c:pt>
+                  <c:pt idx="17">
+                    <c:v>May'26</c:v>
                   </c:pt>
                 </c:lvl>
               </c:multiLvlStrCache>
@@ -990,10 +1013,10 @@
           </c:cat>
           <c:val>
             <c:numRef>
-              <c:f>Sheet1!$C$2:$C$18</c:f>
+              <c:f>Sheet1!$C$2:$C$19</c:f>
               <c:numCache>
                 <c:formatCode>General</c:formatCode>
-                <c:ptCount val="17"/>
+                <c:ptCount val="18"/>
                 <c:pt idx="0">
                   <c:v>32550</c:v>
                 </c:pt>
@@ -1044,6 +1067,9 @@
                 </c:pt>
                 <c:pt idx="16">
                   <c:v>39700</c:v>
+                </c:pt>
+                <c:pt idx="17">
+                  <c:v>38950</c:v>
                 </c:pt>
               </c:numCache>
             </c:numRef>
@@ -1121,9 +1147,9 @@
           </c:marker>
           <c:cat>
             <c:multiLvlStrRef>
-              <c:f>Sheet1!$A$2:$A$18</c:f>
+              <c:f>Sheet1!$A$2:$A$19</c:f>
               <c:multiLvlStrCache>
-                <c:ptCount val="17"/>
+                <c:ptCount val="18"/>
                 <c:lvl>
                   <c:pt idx="0">
                     <c:v>Dec'24</c:v>
@@ -1175,6 +1201,9 @@
                   </c:pt>
                   <c:pt idx="16">
                     <c:v>Apr'26</c:v>
+                  </c:pt>
+                  <c:pt idx="17">
+                    <c:v>May'26</c:v>
                   </c:pt>
                 </c:lvl>
               </c:multiLvlStrCache>
@@ -1182,10 +1211,10 @@
           </c:cat>
           <c:val>
             <c:numRef>
-              <c:f>Sheet1!$D$2:$D$18</c:f>
+              <c:f>Sheet1!$D$2:$D$19</c:f>
               <c:numCache>
                 <c:formatCode>General</c:formatCode>
-                <c:ptCount val="17"/>
+                <c:ptCount val="18"/>
                 <c:pt idx="0">
                   <c:v>28800</c:v>
                 </c:pt>
@@ -1235,7 +1264,10 @@
                   <c:v>29650</c:v>
                 </c:pt>
                 <c:pt idx="16">
-                  <c:v>31000</c:v>
+                  <c:v>29800</c:v>
+                </c:pt>
+                <c:pt idx="17">
+                  <c:v>29250</c:v>
                 </c:pt>
               </c:numCache>
             </c:numRef>
@@ -1313,9 +1345,9 @@
           </c:marker>
           <c:cat>
             <c:multiLvlStrRef>
-              <c:f>Sheet1!$A$2:$A$18</c:f>
+              <c:f>Sheet1!$A$2:$A$19</c:f>
               <c:multiLvlStrCache>
-                <c:ptCount val="17"/>
+                <c:ptCount val="18"/>
                 <c:lvl>
                   <c:pt idx="0">
                     <c:v>Dec'24</c:v>
@@ -1367,6 +1399,9 @@
                   </c:pt>
                   <c:pt idx="16">
                     <c:v>Apr'26</c:v>
+                  </c:pt>
+                  <c:pt idx="17">
+                    <c:v>May'26</c:v>
                   </c:pt>
                 </c:lvl>
               </c:multiLvlStrCache>
@@ -1374,10 +1409,10 @@
           </c:cat>
           <c:val>
             <c:numRef>
-              <c:f>Sheet1!$E$2:$E$18</c:f>
+              <c:f>Sheet1!$E$2:$E$19</c:f>
               <c:numCache>
                 <c:formatCode>General</c:formatCode>
-                <c:ptCount val="17"/>
+                <c:ptCount val="18"/>
                 <c:pt idx="0">
                   <c:v>26200</c:v>
                 </c:pt>
@@ -1427,7 +1462,10 @@
                   <c:v>30200</c:v>
                 </c:pt>
                 <c:pt idx="16">
-                  <c:v>34840</c:v>
+                  <c:v>31920</c:v>
+                </c:pt>
+                <c:pt idx="17">
+                  <c:v>30000</c:v>
                 </c:pt>
               </c:numCache>
             </c:numRef>
@@ -1659,9 +1697,9 @@
           </c:dLbls>
           <c:cat>
             <c:multiLvlStrRef>
-              <c:f>Sheet1!$A$2:$A$18</c:f>
+              <c:f>Sheet1!$A$2:$A$19</c:f>
               <c:multiLvlStrCache>
-                <c:ptCount val="17"/>
+                <c:ptCount val="18"/>
                 <c:lvl>
                   <c:pt idx="0">
                     <c:v>Dec'24</c:v>
@@ -1728,7 +1766,11 @@
                   </c:pt>
                   <c:pt idx="16">
                     <c:v>Apr'26
-R:+239 | N:+340</c:v>
+R:+732 | N:+45</c:v>
+                  </c:pt>
+                  <c:pt idx="17">
+                    <c:v>May'26
+R:-1,939 | N:-889</c:v>
                   </c:pt>
                 </c:lvl>
               </c:multiLvlStrCache>
@@ -1736,10 +1778,10 @@
           </c:cat>
           <c:val>
             <c:numRef>
-              <c:f>Sheet1!$B$2:$B$18</c:f>
+              <c:f>Sheet1!$B$2:$B$19</c:f>
               <c:numCache>
                 <c:formatCode>General</c:formatCode>
-                <c:ptCount val="17"/>
+                <c:ptCount val="18"/>
                 <c:pt idx="0">
                   <c:v>518.69</c:v>
                 </c:pt>
@@ -1789,7 +1831,10 @@
                   <c:v>509.7</c:v>
                 </c:pt>
                 <c:pt idx="16">
-                  <c:v>748.29</c:v>
+                  <c:v>1241.26</c:v>
+                </c:pt>
+                <c:pt idx="17">
+                  <c:v>-698.23</c:v>
                 </c:pt>
               </c:numCache>
             </c:numRef>
@@ -1842,9 +1887,9 @@
           </c:dLbls>
           <c:cat>
             <c:multiLvlStrRef>
-              <c:f>Sheet1!$A$2:$A$18</c:f>
+              <c:f>Sheet1!$A$2:$A$19</c:f>
               <c:multiLvlStrCache>
-                <c:ptCount val="17"/>
+                <c:ptCount val="18"/>
                 <c:lvl>
                   <c:pt idx="0">
                     <c:v>Dec'24</c:v>
@@ -1911,7 +1956,11 @@
                   </c:pt>
                   <c:pt idx="16">
                     <c:v>Apr'26
-R:+239 | N:+340</c:v>
+R:+732 | N:+45</c:v>
+                  </c:pt>
+                  <c:pt idx="17">
+                    <c:v>May'26
+R:-1,939 | N:-889</c:v>
                   </c:pt>
                 </c:lvl>
               </c:multiLvlStrCache>
@@ -1919,10 +1968,10 @@
           </c:cat>
           <c:val>
             <c:numRef>
-              <c:f>Sheet1!$C$2:$C$18</c:f>
+              <c:f>Sheet1!$C$2:$C$19</c:f>
               <c:numCache>
                 <c:formatCode>General</c:formatCode>
-                <c:ptCount val="17"/>
+                <c:ptCount val="18"/>
                 <c:pt idx="0">
                   <c:v>85.71</c:v>
                 </c:pt>
@@ -1972,7 +2021,10 @@
                   <c:v>172.45</c:v>
                 </c:pt>
                 <c:pt idx="16">
-                  <c:v>512.16</c:v>
+                  <c:v>217.12</c:v>
+                </c:pt>
+                <c:pt idx="17">
+                  <c:v>-672.04</c:v>
                 </c:pt>
               </c:numCache>
             </c:numRef>
@@ -2204,9 +2256,9 @@
           </c:dLbls>
           <c:cat>
             <c:multiLvlStrRef>
-              <c:f>Sheet1!$A$2:$A$18</c:f>
+              <c:f>Sheet1!$A$2:$A$19</c:f>
               <c:multiLvlStrCache>
-                <c:ptCount val="17"/>
+                <c:ptCount val="18"/>
                 <c:lvl>
                   <c:pt idx="0">
                     <c:v>Dec'24</c:v>
@@ -2273,7 +2325,11 @@
                   </c:pt>
                   <c:pt idx="16">
                     <c:v>Apr'26
-R:+273 | N:+669</c:v>
+R:+179 | N:-2,213</c:v>
+                  </c:pt>
+                  <c:pt idx="17">
+                    <c:v>May'26
+R:-2,983 | N:-1,429</c:v>
                   </c:pt>
                 </c:lvl>
               </c:multiLvlStrCache>
@@ -2281,10 +2337,10 @@
           </c:cat>
           <c:val>
             <c:numRef>
-              <c:f>Sheet1!$B$2:$B$18</c:f>
+              <c:f>Sheet1!$B$2:$B$19</c:f>
               <c:numCache>
                 <c:formatCode>General</c:formatCode>
-                <c:ptCount val="17"/>
+                <c:ptCount val="18"/>
                 <c:pt idx="0">
                   <c:v>785.24</c:v>
                 </c:pt>
@@ -2334,7 +2390,10 @@
                   <c:v>2456.18</c:v>
                 </c:pt>
                 <c:pt idx="16">
-                  <c:v>2729.48</c:v>
+                  <c:v>2635.19</c:v>
+                </c:pt>
+                <c:pt idx="17">
+                  <c:v>-347.82</c:v>
                 </c:pt>
               </c:numCache>
             </c:numRef>
@@ -2387,9 +2446,9 @@
           </c:dLbls>
           <c:cat>
             <c:multiLvlStrRef>
-              <c:f>Sheet1!$A$2:$A$18</c:f>
+              <c:f>Sheet1!$A$2:$A$19</c:f>
               <c:multiLvlStrCache>
-                <c:ptCount val="17"/>
+                <c:ptCount val="18"/>
                 <c:lvl>
                   <c:pt idx="0">
                     <c:v>Dec'24</c:v>
@@ -2456,7 +2515,11 @@
                   </c:pt>
                   <c:pt idx="16">
                     <c:v>Apr'26
-R:+273 | N:+669</c:v>
+R:+179 | N:-2,213</c:v>
+                  </c:pt>
+                  <c:pt idx="17">
+                    <c:v>May'26
+R:-2,983 | N:-1,429</c:v>
                   </c:pt>
                 </c:lvl>
               </c:multiLvlStrCache>
@@ -2464,10 +2527,10 @@
           </c:cat>
           <c:val>
             <c:numRef>
-              <c:f>Sheet1!$C$2:$C$18</c:f>
+              <c:f>Sheet1!$C$2:$C$19</c:f>
               <c:numCache>
                 <c:formatCode>General</c:formatCode>
-                <c:ptCount val="17"/>
+                <c:ptCount val="18"/>
                 <c:pt idx="0">
                   <c:v>1176.79</c:v>
                 </c:pt>
@@ -2517,7 +2580,10 @@
                   <c:v>4245.83</c:v>
                 </c:pt>
                 <c:pt idx="16">
-                  <c:v>4915.05</c:v>
+                  <c:v>2032.86</c:v>
+                </c:pt>
+                <c:pt idx="17">
+                  <c:v>603.78</c:v>
                 </c:pt>
               </c:numCache>
             </c:numRef>
@@ -3995,7 +4061,7 @@
                 <a:ea typeface="Calibri" pitchFamily="34" charset="-122"/>
                 <a:cs typeface="Calibri" pitchFamily="34" charset="-120"/>
               </a:rPr>
-              <a:t>Period: 2024-12-12 to 2026-04-10  |  17 months</a:t>
+              <a:t>Period: 2024-12-12 to 2026-05-21  |  18 months</a:t>
             </a:r>
             <a:endParaRPr lang="en-US" sz="1200" dirty="0"/>
           </a:p>
@@ -4259,7 +4325,7 @@
                 <a:ea typeface="Calibri" pitchFamily="34" charset="-122"/>
                 <a:cs typeface="Calibri" pitchFamily="34" charset="-120"/>
               </a:rPr>
-              <a:t>Latest:  Raipur +1,800  |  NCR +2,800     •     Avg:  Raipur 32,385  |  NCR 32,835 INR/MT</a:t>
+              <a:t>Latest:  Raipur -1,100  |  NCR -1,600     •     Avg:  Raipur 32,464  |  NCR 32,828 INR/MT</a:t>
             </a:r>
             <a:endParaRPr lang="en-US" sz="1100" dirty="0"/>
           </a:p>
@@ -4562,7 +4628,7 @@
                 <a:ea typeface="Calibri" pitchFamily="34" charset="-122"/>
                 <a:cs typeface="Calibri" pitchFamily="34" charset="-120"/>
               </a:rPr>
-              <a:t>Latest change:  Pallet DRI: +1,250 INR/MT  |  Pig Iron: +2,650 INR/MT  |  Iron Ore DRI: +1,350 INR/MT  |  Silico Manganese: +11.6 INR/kg</a:t>
+              <a:t>Latest change:  Pallet DRI: -550 INR/MT  |  Pig Iron: -750 INR/MT  |  Iron Ore DRI: -550 INR/MT  |  Silico Manganese: -4.8 INR/kg</a:t>
             </a:r>
             <a:endParaRPr lang="en-US" sz="1100" dirty="0"/>
           </a:p>
@@ -4865,7 +4931,7 @@
                 <a:ea typeface="Calibri" pitchFamily="34" charset="-122"/>
                 <a:cs typeface="Calibri" pitchFamily="34" charset="-120"/>
               </a:rPr>
-              <a:t>Latest:  Raipur +239  |  NCR +340     •     Avg:  Raipur 81  |  NCR -91 INR/MT</a:t>
+              <a:t>Latest:  Raipur -1,939  |  NCR -889     •     Avg:  Raipur 65  |  NCR -140 INR/MT</a:t>
             </a:r>
             <a:endParaRPr lang="en-US" sz="1100" dirty="0"/>
           </a:p>
@@ -5168,7 +5234,7 @@
                 <a:ea typeface="Calibri" pitchFamily="34" charset="-122"/>
                 <a:cs typeface="Calibri" pitchFamily="34" charset="-120"/>
               </a:rPr>
-              <a:t>Latest:  Raipur +273  |  NCR +669     •     Avg:  Raipur 711  |  NCR 1,589 INR/MT</a:t>
+              <a:t>Latest:  Raipur -2,983  |  NCR -1,429     •     Avg:  Raipur 647  |  NCR 1,374 INR/MT</a:t>
             </a:r>
             <a:endParaRPr lang="en-US" sz="1100" dirty="0"/>
           </a:p>

</xml_diff>

<commit_message>
Regenerate material change graphs for May 2026 updates
https://claude.ai/code/session_01JHNUtc6iBoKst8eRAudtNW
</commit_message>
<xml_diff>
--- a/output/material_change_graphs.pptx
+++ b/output/material_change_graphs.pptx
@@ -243,7 +243,7 @@
                   </c:pt>
                   <c:pt idx="17">
                     <c:v>May'26
-R:-1,100 | N:-1,600</c:v>
+R:-700 | N:-900</c:v>
                   </c:pt>
                 </c:lvl>
               </c:multiLvlStrCache>
@@ -307,7 +307,7 @@
                   <c:v>35600</c:v>
                 </c:pt>
                 <c:pt idx="17">
-                  <c:v>34500</c:v>
+                  <c:v>34900</c:v>
                 </c:pt>
               </c:numCache>
             </c:numRef>
@@ -433,7 +433,7 @@
                   </c:pt>
                   <c:pt idx="17">
                     <c:v>May'26
-R:-1,100 | N:-1,600</c:v>
+R:-700 | N:-900</c:v>
                   </c:pt>
                 </c:lvl>
               </c:multiLvlStrCache>
@@ -497,7 +497,7 @@
                   <c:v>35800</c:v>
                 </c:pt>
                 <c:pt idx="17">
-                  <c:v>34200</c:v>
+                  <c:v>34900</c:v>
                 </c:pt>
               </c:numCache>
             </c:numRef>
@@ -871,7 +871,7 @@
                   <c:v>25550</c:v>
                 </c:pt>
                 <c:pt idx="17">
-                  <c:v>25000</c:v>
+                  <c:v>25250</c:v>
                 </c:pt>
               </c:numCache>
             </c:numRef>
@@ -1069,7 +1069,7 @@
                   <c:v>39700</c:v>
                 </c:pt>
                 <c:pt idx="17">
-                  <c:v>38950</c:v>
+                  <c:v>38350</c:v>
                 </c:pt>
               </c:numCache>
             </c:numRef>
@@ -1267,7 +1267,7 @@
                   <c:v>29800</c:v>
                 </c:pt>
                 <c:pt idx="17">
-                  <c:v>29250</c:v>
+                  <c:v>29700</c:v>
                 </c:pt>
               </c:numCache>
             </c:numRef>
@@ -1465,7 +1465,7 @@
                   <c:v>31920</c:v>
                 </c:pt>
                 <c:pt idx="17">
-                  <c:v>30000</c:v>
+                  <c:v>29680</c:v>
                 </c:pt>
               </c:numCache>
             </c:numRef>
@@ -1770,7 +1770,7 @@
                   </c:pt>
                   <c:pt idx="17">
                     <c:v>May'26
-R:-1,939 | N:-889</c:v>
+R:-1,859 | N:-636</c:v>
                   </c:pt>
                 </c:lvl>
               </c:multiLvlStrCache>
@@ -1834,7 +1834,7 @@
                   <c:v>1241.26</c:v>
                 </c:pt>
                 <c:pt idx="17">
-                  <c:v>-698.23</c:v>
+                  <c:v>-618.18</c:v>
                 </c:pt>
               </c:numCache>
             </c:numRef>
@@ -1960,7 +1960,7 @@
                   </c:pt>
                   <c:pt idx="17">
                     <c:v>May'26
-R:-1,939 | N:-889</c:v>
+R:-1,859 | N:-636</c:v>
                   </c:pt>
                 </c:lvl>
               </c:multiLvlStrCache>
@@ -2024,7 +2024,7 @@
                   <c:v>217.12</c:v>
                 </c:pt>
                 <c:pt idx="17">
-                  <c:v>-672.04</c:v>
+                  <c:v>-419.08</c:v>
                 </c:pt>
               </c:numCache>
             </c:numRef>
@@ -2329,7 +2329,7 @@
                   </c:pt>
                   <c:pt idx="17">
                     <c:v>May'26
-R:-2,983 | N:-1,429</c:v>
+R:-2,805 | N:-379</c:v>
                   </c:pt>
                 </c:lvl>
               </c:multiLvlStrCache>
@@ -2393,7 +2393,7 @@
                   <c:v>2635.19</c:v>
                 </c:pt>
                 <c:pt idx="17">
-                  <c:v>-347.82</c:v>
+                  <c:v>-169.52</c:v>
                 </c:pt>
               </c:numCache>
             </c:numRef>
@@ -2519,7 +2519,7 @@
                   </c:pt>
                   <c:pt idx="17">
                     <c:v>May'26
-R:-2,983 | N:-1,429</c:v>
+R:-2,805 | N:-379</c:v>
                   </c:pt>
                 </c:lvl>
               </c:multiLvlStrCache>
@@ -2583,7 +2583,7 @@
                   <c:v>2032.86</c:v>
                 </c:pt>
                 <c:pt idx="17">
-                  <c:v>603.78</c:v>
+                  <c:v>1653.57</c:v>
                 </c:pt>
               </c:numCache>
             </c:numRef>
@@ -4061,7 +4061,7 @@
                 <a:ea typeface="Calibri" pitchFamily="34" charset="-122"/>
                 <a:cs typeface="Calibri" pitchFamily="34" charset="-120"/>
               </a:rPr>
-              <a:t>Period: 2024-12-12 to 2026-05-21  |  18 months</a:t>
+              <a:t>Period: 2024-12-12 to 2026-05-28  |  18 months</a:t>
             </a:r>
             <a:endParaRPr lang="en-US" sz="1200" dirty="0"/>
           </a:p>
@@ -4325,7 +4325,7 @@
                 <a:ea typeface="Calibri" pitchFamily="34" charset="-122"/>
                 <a:cs typeface="Calibri" pitchFamily="34" charset="-120"/>
               </a:rPr>
-              <a:t>Latest:  Raipur -1,100  |  NCR -1,600     •     Avg:  Raipur 32,464  |  NCR 32,828 INR/MT</a:t>
+              <a:t>Latest:  Raipur -700  |  NCR -900     •     Avg:  Raipur 32,486  |  NCR 32,867 INR/MT</a:t>
             </a:r>
             <a:endParaRPr lang="en-US" sz="1100" dirty="0"/>
           </a:p>
@@ -4628,7 +4628,7 @@
                 <a:ea typeface="Calibri" pitchFamily="34" charset="-122"/>
                 <a:cs typeface="Calibri" pitchFamily="34" charset="-120"/>
               </a:rPr>
-              <a:t>Latest change:  Pallet DRI: -550 INR/MT  |  Pig Iron: -750 INR/MT  |  Iron Ore DRI: -550 INR/MT  |  Silico Manganese: -4.8 INR/kg</a:t>
+              <a:t>Latest change:  Pallet DRI: -300 INR/MT  |  Pig Iron: -1,350 INR/MT  |  Iron Ore DRI: -100 INR/MT  |  Silico Manganese: -5.6 INR/kg</a:t>
             </a:r>
             <a:endParaRPr lang="en-US" sz="1100" dirty="0"/>
           </a:p>
@@ -4931,7 +4931,7 @@
                 <a:ea typeface="Calibri" pitchFamily="34" charset="-122"/>
                 <a:cs typeface="Calibri" pitchFamily="34" charset="-120"/>
               </a:rPr>
-              <a:t>Latest:  Raipur -1,939  |  NCR -889     •     Avg:  Raipur 65  |  NCR -140 INR/MT</a:t>
+              <a:t>Latest:  Raipur -1,859  |  NCR -636     •     Avg:  Raipur 70  |  NCR -126 INR/MT</a:t>
             </a:r>
             <a:endParaRPr lang="en-US" sz="1100" dirty="0"/>
           </a:p>
@@ -5234,7 +5234,7 @@
                 <a:ea typeface="Calibri" pitchFamily="34" charset="-122"/>
                 <a:cs typeface="Calibri" pitchFamily="34" charset="-120"/>
               </a:rPr>
-              <a:t>Latest:  Raipur -2,983  |  NCR -1,429     •     Avg:  Raipur 647  |  NCR 1,374 INR/MT</a:t>
+              <a:t>Latest:  Raipur -2,805  |  NCR -379     •     Avg:  Raipur 657  |  NCR 1,432 INR/MT</a:t>
             </a:r>
             <a:endParaRPr lang="en-US" sz="1100" dirty="0"/>
           </a:p>

</xml_diff>

<commit_message>
Regenerate material change graphs for Jun–Jul 2026 updates
https://claude.ai/code/session_01JHNUtc6iBoKst8eRAudtNW
</commit_message>
<xml_diff>
--- a/output/material_change_graphs.pptx
+++ b/output/material_change_graphs.pptx
@@ -170,9 +170,9 @@
           </c:dLbls>
           <c:cat>
             <c:multiLvlStrRef>
-              <c:f>Sheet1!$A$2:$A$19</c:f>
+              <c:f>Sheet1!$A$2:$A$21</c:f>
               <c:multiLvlStrCache>
-                <c:ptCount val="18"/>
+                <c:ptCount val="20"/>
                 <c:lvl>
                   <c:pt idx="0">
                     <c:v>Dec'24</c:v>
@@ -244,6 +244,14 @@
                   <c:pt idx="17">
                     <c:v>May'26
 R:-700 | N:-900</c:v>
+                  </c:pt>
+                  <c:pt idx="18">
+                    <c:v>Jun'26
+R:-600 | N:+0.00</c:v>
+                  </c:pt>
+                  <c:pt idx="19">
+                    <c:v>Jul'26
+R:-300 | N:-1,400</c:v>
                   </c:pt>
                 </c:lvl>
               </c:multiLvlStrCache>
@@ -251,10 +259,10 @@
           </c:cat>
           <c:val>
             <c:numRef>
-              <c:f>Sheet1!$B$2:$B$19</c:f>
+              <c:f>Sheet1!$B$2:$B$21</c:f>
               <c:numCache>
                 <c:formatCode>General</c:formatCode>
-                <c:ptCount val="18"/>
+                <c:ptCount val="20"/>
                 <c:pt idx="0">
                   <c:v>31300</c:v>
                 </c:pt>
@@ -308,6 +316,12 @@
                 </c:pt>
                 <c:pt idx="17">
                   <c:v>34900</c:v>
+                </c:pt>
+                <c:pt idx="18">
+                  <c:v>34300</c:v>
+                </c:pt>
+                <c:pt idx="19">
+                  <c:v>34000</c:v>
                 </c:pt>
               </c:numCache>
             </c:numRef>
@@ -360,9 +374,9 @@
           </c:dLbls>
           <c:cat>
             <c:multiLvlStrRef>
-              <c:f>Sheet1!$A$2:$A$19</c:f>
+              <c:f>Sheet1!$A$2:$A$21</c:f>
               <c:multiLvlStrCache>
-                <c:ptCount val="18"/>
+                <c:ptCount val="20"/>
                 <c:lvl>
                   <c:pt idx="0">
                     <c:v>Dec'24</c:v>
@@ -434,6 +448,14 @@
                   <c:pt idx="17">
                     <c:v>May'26
 R:-700 | N:-900</c:v>
+                  </c:pt>
+                  <c:pt idx="18">
+                    <c:v>Jun'26
+R:-600 | N:+0.00</c:v>
+                  </c:pt>
+                  <c:pt idx="19">
+                    <c:v>Jul'26
+R:-300 | N:-1,400</c:v>
                   </c:pt>
                 </c:lvl>
               </c:multiLvlStrCache>
@@ -441,10 +463,10 @@
           </c:cat>
           <c:val>
             <c:numRef>
-              <c:f>Sheet1!$C$2:$C$19</c:f>
+              <c:f>Sheet1!$C$2:$C$21</c:f>
               <c:numCache>
                 <c:formatCode>General</c:formatCode>
-                <c:ptCount val="18"/>
+                <c:ptCount val="20"/>
                 <c:pt idx="0">
                   <c:v>33100</c:v>
                 </c:pt>
@@ -498,6 +520,12 @@
                 </c:pt>
                 <c:pt idx="17">
                   <c:v>34900</c:v>
+                </c:pt>
+                <c:pt idx="18">
+                  <c:v>34900</c:v>
+                </c:pt>
+                <c:pt idx="19">
+                  <c:v>33500</c:v>
                 </c:pt>
               </c:numCache>
             </c:numRef>
@@ -751,9 +779,9 @@
           </c:marker>
           <c:cat>
             <c:multiLvlStrRef>
-              <c:f>Sheet1!$A$2:$A$19</c:f>
+              <c:f>Sheet1!$A$2:$A$21</c:f>
               <c:multiLvlStrCache>
-                <c:ptCount val="18"/>
+                <c:ptCount val="20"/>
                 <c:lvl>
                   <c:pt idx="0">
                     <c:v>Dec'24</c:v>
@@ -808,6 +836,12 @@
                   </c:pt>
                   <c:pt idx="17">
                     <c:v>May'26</c:v>
+                  </c:pt>
+                  <c:pt idx="18">
+                    <c:v>Jun'26</c:v>
+                  </c:pt>
+                  <c:pt idx="19">
+                    <c:v>Jul'26</c:v>
                   </c:pt>
                 </c:lvl>
               </c:multiLvlStrCache>
@@ -815,10 +849,10 @@
           </c:cat>
           <c:val>
             <c:numRef>
-              <c:f>Sheet1!$B$2:$B$19</c:f>
+              <c:f>Sheet1!$B$2:$B$21</c:f>
               <c:numCache>
                 <c:formatCode>General</c:formatCode>
-                <c:ptCount val="18"/>
+                <c:ptCount val="20"/>
                 <c:pt idx="0">
                   <c:v>24200</c:v>
                 </c:pt>
@@ -872,6 +906,12 @@
                 </c:pt>
                 <c:pt idx="17">
                   <c:v>25250</c:v>
+                </c:pt>
+                <c:pt idx="18">
+                  <c:v>24150</c:v>
+                </c:pt>
+                <c:pt idx="19">
+                  <c:v>23100</c:v>
                 </c:pt>
               </c:numCache>
             </c:numRef>
@@ -949,9 +989,9 @@
           </c:marker>
           <c:cat>
             <c:multiLvlStrRef>
-              <c:f>Sheet1!$A$2:$A$19</c:f>
+              <c:f>Sheet1!$A$2:$A$21</c:f>
               <c:multiLvlStrCache>
-                <c:ptCount val="18"/>
+                <c:ptCount val="20"/>
                 <c:lvl>
                   <c:pt idx="0">
                     <c:v>Dec'24</c:v>
@@ -1006,6 +1046,12 @@
                   </c:pt>
                   <c:pt idx="17">
                     <c:v>May'26</c:v>
+                  </c:pt>
+                  <c:pt idx="18">
+                    <c:v>Jun'26</c:v>
+                  </c:pt>
+                  <c:pt idx="19">
+                    <c:v>Jul'26</c:v>
                   </c:pt>
                 </c:lvl>
               </c:multiLvlStrCache>
@@ -1013,10 +1059,10 @@
           </c:cat>
           <c:val>
             <c:numRef>
-              <c:f>Sheet1!$C$2:$C$19</c:f>
+              <c:f>Sheet1!$C$2:$C$21</c:f>
               <c:numCache>
                 <c:formatCode>General</c:formatCode>
-                <c:ptCount val="18"/>
+                <c:ptCount val="20"/>
                 <c:pt idx="0">
                   <c:v>32550</c:v>
                 </c:pt>
@@ -1070,6 +1116,12 @@
                 </c:pt>
                 <c:pt idx="17">
                   <c:v>38350</c:v>
+                </c:pt>
+                <c:pt idx="18">
+                  <c:v>37150</c:v>
+                </c:pt>
+                <c:pt idx="19">
+                  <c:v>37550</c:v>
                 </c:pt>
               </c:numCache>
             </c:numRef>
@@ -1147,9 +1199,9 @@
           </c:marker>
           <c:cat>
             <c:multiLvlStrRef>
-              <c:f>Sheet1!$A$2:$A$19</c:f>
+              <c:f>Sheet1!$A$2:$A$21</c:f>
               <c:multiLvlStrCache>
-                <c:ptCount val="18"/>
+                <c:ptCount val="20"/>
                 <c:lvl>
                   <c:pt idx="0">
                     <c:v>Dec'24</c:v>
@@ -1204,6 +1256,12 @@
                   </c:pt>
                   <c:pt idx="17">
                     <c:v>May'26</c:v>
+                  </c:pt>
+                  <c:pt idx="18">
+                    <c:v>Jun'26</c:v>
+                  </c:pt>
+                  <c:pt idx="19">
+                    <c:v>Jul'26</c:v>
                   </c:pt>
                 </c:lvl>
               </c:multiLvlStrCache>
@@ -1211,10 +1269,10 @@
           </c:cat>
           <c:val>
             <c:numRef>
-              <c:f>Sheet1!$D$2:$D$19</c:f>
+              <c:f>Sheet1!$D$2:$D$21</c:f>
               <c:numCache>
                 <c:formatCode>General</c:formatCode>
-                <c:ptCount val="18"/>
+                <c:ptCount val="20"/>
                 <c:pt idx="0">
                   <c:v>28800</c:v>
                 </c:pt>
@@ -1268,6 +1326,12 @@
                 </c:pt>
                 <c:pt idx="17">
                   <c:v>29700</c:v>
+                </c:pt>
+                <c:pt idx="18">
+                  <c:v>28250</c:v>
+                </c:pt>
+                <c:pt idx="19">
+                  <c:v>27100</c:v>
                 </c:pt>
               </c:numCache>
             </c:numRef>
@@ -1345,9 +1409,9 @@
           </c:marker>
           <c:cat>
             <c:multiLvlStrRef>
-              <c:f>Sheet1!$A$2:$A$19</c:f>
+              <c:f>Sheet1!$A$2:$A$21</c:f>
               <c:multiLvlStrCache>
-                <c:ptCount val="18"/>
+                <c:ptCount val="20"/>
                 <c:lvl>
                   <c:pt idx="0">
                     <c:v>Dec'24</c:v>
@@ -1402,6 +1466,12 @@
                   </c:pt>
                   <c:pt idx="17">
                     <c:v>May'26</c:v>
+                  </c:pt>
+                  <c:pt idx="18">
+                    <c:v>Jun'26</c:v>
+                  </c:pt>
+                  <c:pt idx="19">
+                    <c:v>Jul'26</c:v>
                   </c:pt>
                 </c:lvl>
               </c:multiLvlStrCache>
@@ -1409,10 +1479,10 @@
           </c:cat>
           <c:val>
             <c:numRef>
-              <c:f>Sheet1!$E$2:$E$19</c:f>
+              <c:f>Sheet1!$E$2:$E$21</c:f>
               <c:numCache>
                 <c:formatCode>General</c:formatCode>
-                <c:ptCount val="18"/>
+                <c:ptCount val="20"/>
                 <c:pt idx="0">
                   <c:v>26200</c:v>
                 </c:pt>
@@ -1466,6 +1536,12 @@
                 </c:pt>
                 <c:pt idx="17">
                   <c:v>29680</c:v>
+                </c:pt>
+                <c:pt idx="18">
+                  <c:v>30880</c:v>
+                </c:pt>
+                <c:pt idx="19">
+                  <c:v>30360.000000000004</c:v>
                 </c:pt>
               </c:numCache>
             </c:numRef>
@@ -1697,9 +1773,9 @@
           </c:dLbls>
           <c:cat>
             <c:multiLvlStrRef>
-              <c:f>Sheet1!$A$2:$A$19</c:f>
+              <c:f>Sheet1!$A$2:$A$21</c:f>
               <c:multiLvlStrCache>
-                <c:ptCount val="18"/>
+                <c:ptCount val="20"/>
                 <c:lvl>
                   <c:pt idx="0">
                     <c:v>Dec'24</c:v>
@@ -1771,6 +1847,14 @@
                   <c:pt idx="17">
                     <c:v>May'26
 R:-1,859 | N:-636</c:v>
+                  </c:pt>
+                  <c:pt idx="18">
+                    <c:v>Jun'26
+R:+831 | N:+340</c:v>
+                  </c:pt>
+                  <c:pt idx="19">
+                    <c:v>Jul'26
+R:-72 | N:+101</c:v>
                   </c:pt>
                 </c:lvl>
               </c:multiLvlStrCache>
@@ -1778,10 +1862,10 @@
           </c:cat>
           <c:val>
             <c:numRef>
-              <c:f>Sheet1!$B$2:$B$19</c:f>
+              <c:f>Sheet1!$B$2:$B$21</c:f>
               <c:numCache>
                 <c:formatCode>General</c:formatCode>
-                <c:ptCount val="18"/>
+                <c:ptCount val="20"/>
                 <c:pt idx="0">
                   <c:v>518.69</c:v>
                 </c:pt>
@@ -1835,6 +1919,12 @@
                 </c:pt>
                 <c:pt idx="17">
                   <c:v>-618.18</c:v>
+                </c:pt>
+                <c:pt idx="18">
+                  <c:v>213.13</c:v>
+                </c:pt>
+                <c:pt idx="19">
+                  <c:v>140.93</c:v>
                 </c:pt>
               </c:numCache>
             </c:numRef>
@@ -1887,9 +1977,9 @@
           </c:dLbls>
           <c:cat>
             <c:multiLvlStrRef>
-              <c:f>Sheet1!$A$2:$A$19</c:f>
+              <c:f>Sheet1!$A$2:$A$21</c:f>
               <c:multiLvlStrCache>
-                <c:ptCount val="18"/>
+                <c:ptCount val="20"/>
                 <c:lvl>
                   <c:pt idx="0">
                     <c:v>Dec'24</c:v>
@@ -1961,6 +2051,14 @@
                   <c:pt idx="17">
                     <c:v>May'26
 R:-1,859 | N:-636</c:v>
+                  </c:pt>
+                  <c:pt idx="18">
+                    <c:v>Jun'26
+R:+831 | N:+340</c:v>
+                  </c:pt>
+                  <c:pt idx="19">
+                    <c:v>Jul'26
+R:-72 | N:+101</c:v>
                   </c:pt>
                 </c:lvl>
               </c:multiLvlStrCache>
@@ -1968,10 +2066,10 @@
           </c:cat>
           <c:val>
             <c:numRef>
-              <c:f>Sheet1!$C$2:$C$19</c:f>
+              <c:f>Sheet1!$C$2:$C$21</c:f>
               <c:numCache>
                 <c:formatCode>General</c:formatCode>
-                <c:ptCount val="18"/>
+                <c:ptCount val="20"/>
                 <c:pt idx="0">
                   <c:v>85.71</c:v>
                 </c:pt>
@@ -2025,6 +2123,12 @@
                 </c:pt>
                 <c:pt idx="17">
                   <c:v>-419.08</c:v>
+                </c:pt>
+                <c:pt idx="18">
+                  <c:v>-78.78</c:v>
+                </c:pt>
+                <c:pt idx="19">
+                  <c:v>22.59</c:v>
                 </c:pt>
               </c:numCache>
             </c:numRef>
@@ -2256,9 +2360,9 @@
           </c:dLbls>
           <c:cat>
             <c:multiLvlStrRef>
-              <c:f>Sheet1!$A$2:$A$19</c:f>
+              <c:f>Sheet1!$A$2:$A$21</c:f>
               <c:multiLvlStrCache>
-                <c:ptCount val="18"/>
+                <c:ptCount val="20"/>
                 <c:lvl>
                   <c:pt idx="0">
                     <c:v>Dec'24</c:v>
@@ -2330,6 +2434,14 @@
                   <c:pt idx="17">
                     <c:v>May'26
 R:-2,805 | N:-379</c:v>
+                  </c:pt>
+                  <c:pt idx="18">
+                    <c:v>Jun'26
+R:+192 | N:-455</c:v>
+                  </c:pt>
+                  <c:pt idx="19">
+                    <c:v>Jul'26
+R:-364 | N:-1,139</c:v>
                   </c:pt>
                 </c:lvl>
               </c:multiLvlStrCache>
@@ -2337,10 +2449,10 @@
           </c:cat>
           <c:val>
             <c:numRef>
-              <c:f>Sheet1!$B$2:$B$19</c:f>
+              <c:f>Sheet1!$B$2:$B$21</c:f>
               <c:numCache>
                 <c:formatCode>General</c:formatCode>
-                <c:ptCount val="18"/>
+                <c:ptCount val="20"/>
                 <c:pt idx="0">
                   <c:v>785.24</c:v>
                 </c:pt>
@@ -2394,6 +2506,12 @@
                 </c:pt>
                 <c:pt idx="17">
                   <c:v>-169.52</c:v>
+                </c:pt>
+                <c:pt idx="18">
+                  <c:v>22.04</c:v>
+                </c:pt>
+                <c:pt idx="19">
+                  <c:v>-341.95</c:v>
                 </c:pt>
               </c:numCache>
             </c:numRef>
@@ -2446,9 +2564,9 @@
           </c:dLbls>
           <c:cat>
             <c:multiLvlStrRef>
-              <c:f>Sheet1!$A$2:$A$19</c:f>
+              <c:f>Sheet1!$A$2:$A$21</c:f>
               <c:multiLvlStrCache>
-                <c:ptCount val="18"/>
+                <c:ptCount val="20"/>
                 <c:lvl>
                   <c:pt idx="0">
                     <c:v>Dec'24</c:v>
@@ -2520,6 +2638,14 @@
                   <c:pt idx="17">
                     <c:v>May'26
 R:-2,805 | N:-379</c:v>
+                  </c:pt>
+                  <c:pt idx="18">
+                    <c:v>Jun'26
+R:+192 | N:-455</c:v>
+                  </c:pt>
+                  <c:pt idx="19">
+                    <c:v>Jul'26
+R:-364 | N:-1,139</c:v>
                   </c:pt>
                 </c:lvl>
               </c:multiLvlStrCache>
@@ -2527,10 +2653,10 @@
           </c:cat>
           <c:val>
             <c:numRef>
-              <c:f>Sheet1!$C$2:$C$19</c:f>
+              <c:f>Sheet1!$C$2:$C$21</c:f>
               <c:numCache>
                 <c:formatCode>General</c:formatCode>
-                <c:ptCount val="18"/>
+                <c:ptCount val="20"/>
                 <c:pt idx="0">
                   <c:v>1176.79</c:v>
                 </c:pt>
@@ -2584,6 +2710,12 @@
                 </c:pt>
                 <c:pt idx="17">
                   <c:v>1653.57</c:v>
+                </c:pt>
+                <c:pt idx="18">
+                  <c:v>1198.99</c:v>
+                </c:pt>
+                <c:pt idx="19">
+                  <c:v>59.97</c:v>
                 </c:pt>
               </c:numCache>
             </c:numRef>
@@ -4061,7 +4193,7 @@
                 <a:ea typeface="Calibri" pitchFamily="34" charset="-122"/>
                 <a:cs typeface="Calibri" pitchFamily="34" charset="-120"/>
               </a:rPr>
-              <a:t>Period: 2024-12-12 to 2026-05-28  |  18 months</a:t>
+              <a:t>Period: 2024-12-12 to 2026-07-08  |  20 months</a:t>
             </a:r>
             <a:endParaRPr lang="en-US" sz="1200" dirty="0"/>
           </a:p>
@@ -4325,7 +4457,7 @@
                 <a:ea typeface="Calibri" pitchFamily="34" charset="-122"/>
                 <a:cs typeface="Calibri" pitchFamily="34" charset="-120"/>
               </a:rPr>
-              <a:t>Latest:  Raipur -700  |  NCR -900     •     Avg:  Raipur 32,486  |  NCR 32,867 INR/MT</a:t>
+              <a:t>Latest:  Raipur -300  |  NCR -1,400     •     Avg:  Raipur 32,653  |  NCR 33,000 INR/MT</a:t>
             </a:r>
             <a:endParaRPr lang="en-US" sz="1100" dirty="0"/>
           </a:p>
@@ -4628,7 +4760,7 @@
                 <a:ea typeface="Calibri" pitchFamily="34" charset="-122"/>
                 <a:cs typeface="Calibri" pitchFamily="34" charset="-120"/>
               </a:rPr>
-              <a:t>Latest change:  Pallet DRI: -300 INR/MT  |  Pig Iron: -1,350 INR/MT  |  Iron Ore DRI: -100 INR/MT  |  Silico Manganese: -5.6 INR/kg</a:t>
+              <a:t>Latest change:  Pallet DRI: -1,050 INR/MT  |  Pig Iron: +400 INR/MT  |  Iron Ore DRI: -1,150 INR/MT  |  Silico Manganese: -1.3 INR/kg</a:t>
             </a:r>
             <a:endParaRPr lang="en-US" sz="1100" dirty="0"/>
           </a:p>
@@ -4931,7 +5063,7 @@
                 <a:ea typeface="Calibri" pitchFamily="34" charset="-122"/>
                 <a:cs typeface="Calibri" pitchFamily="34" charset="-120"/>
               </a:rPr>
-              <a:t>Latest:  Raipur -1,859  |  NCR -636     •     Avg:  Raipur 70  |  NCR -126 INR/MT</a:t>
+              <a:t>Latest:  Raipur -72  |  NCR +101     •     Avg:  Raipur 80  |  NCR -116 INR/MT</a:t>
             </a:r>
             <a:endParaRPr lang="en-US" sz="1100" dirty="0"/>
           </a:p>
@@ -5234,7 +5366,7 @@
                 <a:ea typeface="Calibri" pitchFamily="34" charset="-122"/>
                 <a:cs typeface="Calibri" pitchFamily="34" charset="-120"/>
               </a:rPr>
-              <a:t>Latest:  Raipur -2,805  |  NCR -379     •     Avg:  Raipur 657  |  NCR 1,432 INR/MT</a:t>
+              <a:t>Latest:  Raipur -364  |  NCR -1,139     •     Avg:  Raipur 575  |  NCR 1,352 INR/MT</a:t>
             </a:r>
             <a:endParaRPr lang="en-US" sz="1100" dirty="0"/>
           </a:p>

</xml_diff>

<commit_message>
Regenerate material change graphs for 2026-07-14 update
https://claude.ai/code/session_01JHNUtc6iBoKst8eRAudtNW
</commit_message>
<xml_diff>
--- a/output/material_change_graphs.pptx
+++ b/output/material_change_graphs.pptx
@@ -251,7 +251,7 @@
                   </c:pt>
                   <c:pt idx="19">
                     <c:v>Jul'26
-R:-300 | N:-1,400</c:v>
+R:-300 | N:-1,600</c:v>
                   </c:pt>
                 </c:lvl>
               </c:multiLvlStrCache>
@@ -455,7 +455,7 @@
                   </c:pt>
                   <c:pt idx="19">
                     <c:v>Jul'26
-R:-300 | N:-1,400</c:v>
+R:-300 | N:-1,600</c:v>
                   </c:pt>
                 </c:lvl>
               </c:multiLvlStrCache>
@@ -525,7 +525,7 @@
                   <c:v>34900</c:v>
                 </c:pt>
                 <c:pt idx="19">
-                  <c:v>33500</c:v>
+                  <c:v>33300</c:v>
                 </c:pt>
               </c:numCache>
             </c:numRef>
@@ -911,7 +911,7 @@
                   <c:v>24150</c:v>
                 </c:pt>
                 <c:pt idx="19">
-                  <c:v>23100</c:v>
+                  <c:v>22950</c:v>
                 </c:pt>
               </c:numCache>
             </c:numRef>
@@ -1121,7 +1121,7 @@
                   <c:v>37150</c:v>
                 </c:pt>
                 <c:pt idx="19">
-                  <c:v>37550</c:v>
+                  <c:v>38000</c:v>
                 </c:pt>
               </c:numCache>
             </c:numRef>
@@ -1331,7 +1331,7 @@
                   <c:v>28250</c:v>
                 </c:pt>
                 <c:pt idx="19">
-                  <c:v>27100</c:v>
+                  <c:v>26900</c:v>
                 </c:pt>
               </c:numCache>
             </c:numRef>
@@ -1541,7 +1541,7 @@
                   <c:v>30880</c:v>
                 </c:pt>
                 <c:pt idx="19">
-                  <c:v>30360.000000000004</c:v>
+                  <c:v>30000</c:v>
                 </c:pt>
               </c:numCache>
             </c:numRef>
@@ -1854,7 +1854,7 @@
                   </c:pt>
                   <c:pt idx="19">
                     <c:v>Jul'26
-R:-72 | N:+101</c:v>
+R:-516 | N:-67</c:v>
                   </c:pt>
                 </c:lvl>
               </c:multiLvlStrCache>
@@ -1924,7 +1924,7 @@
                   <c:v>213.13</c:v>
                 </c:pt>
                 <c:pt idx="19">
-                  <c:v>140.93</c:v>
+                  <c:v>-302.61</c:v>
                 </c:pt>
               </c:numCache>
             </c:numRef>
@@ -2058,7 +2058,7 @@
                   </c:pt>
                   <c:pt idx="19">
                     <c:v>Jul'26
-R:-72 | N:+101</c:v>
+R:-516 | N:-67</c:v>
                   </c:pt>
                 </c:lvl>
               </c:multiLvlStrCache>
@@ -2128,7 +2128,7 @@
                   <c:v>-78.78</c:v>
                 </c:pt>
                 <c:pt idx="19">
-                  <c:v>22.59</c:v>
+                  <c:v>-145.94</c:v>
                 </c:pt>
               </c:numCache>
             </c:numRef>
@@ -2441,7 +2441,7 @@
                   </c:pt>
                   <c:pt idx="19">
                     <c:v>Jul'26
-R:-364 | N:-1,139</c:v>
+R:-1,157 | N:-1,756</c:v>
                   </c:pt>
                 </c:lvl>
               </c:multiLvlStrCache>
@@ -2511,7 +2511,7 @@
                   <c:v>22.04</c:v>
                 </c:pt>
                 <c:pt idx="19">
-                  <c:v>-341.95</c:v>
+                  <c:v>-1134.63</c:v>
                 </c:pt>
               </c:numCache>
             </c:numRef>
@@ -2645,7 +2645,7 @@
                   </c:pt>
                   <c:pt idx="19">
                     <c:v>Jul'26
-R:-364 | N:-1,139</c:v>
+R:-1,157 | N:-1,756</c:v>
                   </c:pt>
                 </c:lvl>
               </c:multiLvlStrCache>
@@ -2715,7 +2715,7 @@
                   <c:v>1198.99</c:v>
                 </c:pt>
                 <c:pt idx="19">
-                  <c:v>59.97</c:v>
+                  <c:v>-557.51</c:v>
                 </c:pt>
               </c:numCache>
             </c:numRef>
@@ -4193,7 +4193,7 @@
                 <a:ea typeface="Calibri" pitchFamily="34" charset="-122"/>
                 <a:cs typeface="Calibri" pitchFamily="34" charset="-120"/>
               </a:rPr>
-              <a:t>Period: 2024-12-12 to 2026-07-08  |  20 months</a:t>
+              <a:t>Period: 2024-12-12 to 2026-07-14  |  20 months</a:t>
             </a:r>
             <a:endParaRPr lang="en-US" sz="1200" dirty="0"/>
           </a:p>
@@ -4457,7 +4457,7 @@
                 <a:ea typeface="Calibri" pitchFamily="34" charset="-122"/>
                 <a:cs typeface="Calibri" pitchFamily="34" charset="-120"/>
               </a:rPr>
-              <a:t>Latest:  Raipur -300  |  NCR -1,400     •     Avg:  Raipur 32,653  |  NCR 33,000 INR/MT</a:t>
+              <a:t>Latest:  Raipur -300  |  NCR -1,600     •     Avg:  Raipur 32,653  |  NCR 32,990 INR/MT</a:t>
             </a:r>
             <a:endParaRPr lang="en-US" sz="1100" dirty="0"/>
           </a:p>
@@ -4760,7 +4760,7 @@
                 <a:ea typeface="Calibri" pitchFamily="34" charset="-122"/>
                 <a:cs typeface="Calibri" pitchFamily="34" charset="-120"/>
               </a:rPr>
-              <a:t>Latest change:  Pallet DRI: -1,050 INR/MT  |  Pig Iron: +400 INR/MT  |  Iron Ore DRI: -1,150 INR/MT  |  Silico Manganese: -1.3 INR/kg</a:t>
+              <a:t>Latest change:  Pallet DRI: -1,200 INR/MT  |  Pig Iron: +850 INR/MT  |  Iron Ore DRI: -1,350 INR/MT  |  Silico Manganese: -2.2 INR/kg</a:t>
             </a:r>
             <a:endParaRPr lang="en-US" sz="1100" dirty="0"/>
           </a:p>
@@ -5063,7 +5063,7 @@
                 <a:ea typeface="Calibri" pitchFamily="34" charset="-122"/>
                 <a:cs typeface="Calibri" pitchFamily="34" charset="-120"/>
               </a:rPr>
-              <a:t>Latest:  Raipur -72  |  NCR +101     •     Avg:  Raipur 80  |  NCR -116 INR/MT</a:t>
+              <a:t>Latest:  Raipur -516  |  NCR -67     •     Avg:  Raipur 58  |  NCR -125 INR/MT</a:t>
             </a:r>
             <a:endParaRPr lang="en-US" sz="1100" dirty="0"/>
           </a:p>
@@ -5366,7 +5366,7 @@
                 <a:ea typeface="Calibri" pitchFamily="34" charset="-122"/>
                 <a:cs typeface="Calibri" pitchFamily="34" charset="-120"/>
               </a:rPr>
-              <a:t>Latest:  Raipur -364  |  NCR -1,139     •     Avg:  Raipur 575  |  NCR 1,352 INR/MT</a:t>
+              <a:t>Latest:  Raipur -1,157  |  NCR -1,756     •     Avg:  Raipur 535  |  NCR 1,321 INR/MT</a:t>
             </a:r>
             <a:endParaRPr lang="en-US" sz="1100" dirty="0"/>
           </a:p>

</xml_diff>